<commit_message>
docs: correct the confidence claim and add the two-sided story
The README previously said the confidence band held across domains on the
strength of a single run. Re-running the same message gave a different answer,
so the section now explains what was wrong, why a catch-all clause made the
model certain about anything, and reports the verification: five consecutive
runs per borderline message at pinned temperature, ten of ten unsure.

Adds the either-side section. Whether a request is in scope is a property of
the request rather than of who is reading, so a captured run replays from
either perspective without reclassification.

Co-Authored-By: Claude Opus 5 <noreply@anthropic.com>
</commit_message>
<xml_diff>
--- a/deck/chief-of-staff.pptx
+++ b/deck/chief-of-staff.pptx
@@ -1215,7 +1215,7 @@
           <a:p>
             <a:r>
               <a:rPr lang="en-US" dirty="0"/>
-              <a:t>This pre-empts the most obvious skeptical question. Two domains, two currencies, two timezones, one prompt.</a:t>
+              <a:t>Two domains, two currencies, two timezones, one prompt. The 10/10 is five reruns per message after the catch-all fix — the earlier version of this slide claimed stability from one observation, which is exactly the mistake this project keeps catching.</a:t>
             </a:r>
             <a:endParaRPr lang="en-US" dirty="0"/>
           </a:p>
@@ -2079,7 +2079,7 @@
                 <a:ea typeface="Courier New" pitchFamily="34" charset="-122"/>
                 <a:cs typeface="Courier New" pitchFamily="34" charset="-120"/>
               </a:rPr>
-              <a:t>Model</a:t>
+              <a:t>Both sides</a:t>
             </a:r>
             <a:endParaRPr lang="en-US" sz="1200" dirty="0"/>
           </a:p>
@@ -2121,7 +2121,7 @@
                 <a:ea typeface="Calibri" pitchFamily="34" charset="-122"/>
                 <a:cs typeface="Calibri" pitchFamily="34" charset="-120"/>
               </a:rPr>
-              <a:t>Per-seat subscription. Paid inference, not a free tier: a real statement of work carries client names and fees.</a:t>
+              <a:t>The shop that hired them has the same problem inverted, and the same engine answers it. One contract, one thread, two readings of who is late. Growth without becoming a thinner product.</a:t>
             </a:r>
             <a:endParaRPr lang="en-US" sz="1300" dirty="0"/>
           </a:p>
@@ -2202,7 +2202,7 @@
                 <a:ea typeface="Calibri" pitchFamily="34" charset="-122"/>
                 <a:cs typeface="Calibri" pitchFamily="34" charset="-120"/>
               </a:rPr>
-              <a:t>Contract ingestion, message classification, obligation ledger, drafting with safety rails, and the review surface — running end to end on two contracts.</a:t>
+              <a:t>Contract ingestion, message classification, obligation ledger, drafting with safety rails, and the review surface — end to end, on two contracts, from either side.</a:t>
             </a:r>
             <a:endParaRPr lang="en-US" sz="1300" dirty="0"/>
           </a:p>
@@ -8398,27 +8398,24 @@
         </p:nvSpPr>
         <p:spPr>
           <a:xfrm>
-            <a:off x="8887968" y="2670048"/>
-            <a:ext cx="2423160" cy="548640"/>
-          </a:xfrm>
-          <a:prstGeom prst="rect">
-            <a:avLst/>
-          </a:prstGeom>
-          <a:noFill/>
-          <a:ln/>
-        </p:spPr>
-        <p:txBody>
-          <a:bodyPr wrap="square" lIns="0" tIns="0" rIns="0" bIns="0" rtlCol="0" anchor="ctr"/>
-          <a:lstStyle/>
-          <a:p>
-            <a:pPr indent="0" marL="0">
-              <a:lnSpc>
-                <a:spcPts val="2000"/>
-              </a:lnSpc>
-              <a:buNone/>
-            </a:pPr>
-            <a:r>
-              <a:rPr lang="en-US" sz="1500" b="1" dirty="0">
+            <a:off x="8887968" y="2633472"/>
+            <a:ext cx="2423160" cy="640080"/>
+          </a:xfrm>
+          <a:prstGeom prst="rect">
+            <a:avLst/>
+          </a:prstGeom>
+          <a:noFill/>
+          <a:ln/>
+        </p:spPr>
+        <p:txBody>
+          <a:bodyPr wrap="square" lIns="0" tIns="0" rIns="0" bIns="0" rtlCol="0" anchor="ctr"/>
+          <a:lstStyle/>
+          <a:p>
+            <a:pPr indent="0" marL="0">
+              <a:buNone/>
+            </a:pPr>
+            <a:r>
+              <a:rPr lang="en-US" sz="3400" b="1" dirty="0">
                 <a:solidFill>
                   <a:srgbClr val="FFFFFF"/>
                 </a:solidFill>
@@ -8426,9 +8423,9 @@
                 <a:ea typeface="Calibri" pitchFamily="34" charset="-122"/>
                 <a:cs typeface="Calibri" pitchFamily="34" charset="-120"/>
               </a:rPr>
-              <a:t>The unsure band held</a:t>
-            </a:r>
-            <a:endParaRPr lang="en-US" sz="1500" dirty="0"/>
+              <a:t>10 / 10</a:t>
+            </a:r>
+            <a:endParaRPr lang="en-US" sz="3400" dirty="0"/>
           </a:p>
         </p:txBody>
       </p:sp>
@@ -8441,7 +8438,7 @@
         <p:spPr>
           <a:xfrm>
             <a:off x="8887968" y="3346704"/>
-            <a:ext cx="2423160" cy="1645920"/>
+            <a:ext cx="2423160" cy="1828800"/>
           </a:xfrm>
           <a:prstGeom prst="rect">
             <a:avLst/>
@@ -8455,12 +8452,12 @@
           <a:p>
             <a:pPr indent="0" marL="0">
               <a:lnSpc>
-                <a:spcPts val="1700"/>
+                <a:spcPts val="1600"/>
               </a:lnSpc>
               <a:buNone/>
             </a:pPr>
             <a:r>
-              <a:rPr lang="en-US" sz="1200" dirty="0">
+              <a:rPr lang="en-US" sz="1150" dirty="0">
                 <a:solidFill>
                   <a:srgbClr val="CFC9F2"/>
                 </a:solidFill>
@@ -8468,9 +8465,9 @@
                 <a:ea typeface="Calibri" pitchFamily="34" charset="-122"/>
                 <a:cs typeface="Calibri" pitchFamily="34" charset="-120"/>
               </a:rPr>
-              <a:t>“Could the logo animate?” and “just another column” are the same shape — and each was the single unsure verdict in its thread.</a:t>
-            </a:r>
-            <a:endParaRPr lang="en-US" sz="1200" dirty="0"/>
+              <a:t>The borderline message in each thread returns “unsure” — five consecutive runs each, temperature pinned. We first claimed this from a single run, then re-ran it and found it was not true yet.</a:t>
+            </a:r>
+            <a:endParaRPr lang="en-US" sz="1150" dirty="0"/>
           </a:p>
         </p:txBody>
       </p:sp>
@@ -9076,7 +9073,7 @@
                 <a:ea typeface="Calibri" pitchFamily="34" charset="-122"/>
                 <a:cs typeface="Calibri" pitchFamily="34" charset="-120"/>
               </a:rPr>
-              <a:t>One project's run wiping another's</a:t>
+              <a:t>A claim that was true once, not always</a:t>
             </a:r>
             <a:endParaRPr lang="en-US" sz="1550" dirty="0"/>
           </a:p>
@@ -9118,7 +9115,7 @@
                 <a:ea typeface="Calibri" pitchFamily="34" charset="-122"/>
                 <a:cs typeface="Calibri" pitchFamily="34" charset="-120"/>
               </a:rPr>
-              <a:t>Same root cause. Once we saw the shape twice, we audited for it and found a third instance before it bit.</a:t>
+              <a:t>We said the confidence band held, on one run. Re-running gave a different answer. A catch-all clause let the model be certain about anything, so nothing was ever ambiguous — the fix was a rule, not a retry.</a:t>
             </a:r>
             <a:endParaRPr lang="en-US" sz="1150" dirty="0"/>
           </a:p>

</xml_diff>

<commit_message>
fix: deck titles overran their boxes onto the content below
Every title wraps to two lines at 38pt across the full width, needing 1.29
inches inside a box declared at 1.0. The overspill landed within four
hundredths of an inch of the first card on two slides.

Titles are now shorter, which fits them on one line and reads better, and the
box carries headroom regardless. Slide 9's third finding was also longer than
its card.

Found by measuring text length against box geometry, since LibreOffice cannot
render here — an approximation, so a human should still open it once.

Co-Authored-By: Claude Opus 5 <noreply@anthropic.com>
</commit_message>
<xml_diff>
--- a/deck/chief-of-staff.pptx
+++ b/deck/chief-of-staff.pptx
@@ -2327,7 +2327,7 @@
         <p:spPr>
           <a:xfrm>
             <a:off x="640080" y="658368"/>
-            <a:ext cx="10881360" cy="914400"/>
+            <a:ext cx="10881360" cy="1280160"/>
           </a:xfrm>
           <a:prstGeom prst="rect">
             <a:avLst/>
@@ -2351,7 +2351,7 @@
                 <a:ea typeface="Cambria" pitchFamily="34" charset="-122"/>
                 <a:cs typeface="Cambria" pitchFamily="34" charset="-120"/>
               </a:rPr>
-              <a:t>Two things go wrong, and neither lives in the inbox</a:t>
+              <a:t>Two things go wrong, neither in the inbox</a:t>
             </a:r>
             <a:endParaRPr lang="en-US" sz="3800" dirty="0"/>
           </a:p>
@@ -2365,7 +2365,7 @@
         </p:nvSpPr>
         <p:spPr>
           <a:xfrm>
-            <a:off x="640080" y="1874520"/>
+            <a:off x="640080" y="2011680"/>
             <a:ext cx="6766560" cy="1463040"/>
           </a:xfrm>
           <a:prstGeom prst="roundRect">
@@ -2392,7 +2392,7 @@
         </p:nvSpPr>
         <p:spPr>
           <a:xfrm>
-            <a:off x="914400" y="2167128"/>
+            <a:off x="914400" y="2304288"/>
             <a:ext cx="384048" cy="384048"/>
           </a:xfrm>
           <a:prstGeom prst="ellipse">
@@ -2412,7 +2412,7 @@
         </p:nvSpPr>
         <p:spPr>
           <a:xfrm>
-            <a:off x="914400" y="2167128"/>
+            <a:off x="914400" y="2304288"/>
             <a:ext cx="384048" cy="384048"/>
           </a:xfrm>
           <a:prstGeom prst="rect">
@@ -2451,7 +2451,7 @@
         </p:nvSpPr>
         <p:spPr>
           <a:xfrm>
-            <a:off x="1481328" y="2112264"/>
+            <a:off x="1481328" y="2249424"/>
             <a:ext cx="5669280" cy="329184"/>
           </a:xfrm>
           <a:prstGeom prst="rect">
@@ -2490,7 +2490,7 @@
         </p:nvSpPr>
         <p:spPr>
           <a:xfrm>
-            <a:off x="1481328" y="2496312"/>
+            <a:off x="1481328" y="2633472"/>
             <a:ext cx="5669280" cy="731520"/>
           </a:xfrm>
           <a:prstGeom prst="rect">
@@ -2532,7 +2532,7 @@
         </p:nvSpPr>
         <p:spPr>
           <a:xfrm>
-            <a:off x="640080" y="3657600"/>
+            <a:off x="640080" y="3794760"/>
             <a:ext cx="6766560" cy="1463040"/>
           </a:xfrm>
           <a:prstGeom prst="roundRect">
@@ -2559,7 +2559,7 @@
         </p:nvSpPr>
         <p:spPr>
           <a:xfrm>
-            <a:off x="914400" y="3950208"/>
+            <a:off x="914400" y="4087368"/>
             <a:ext cx="384048" cy="384048"/>
           </a:xfrm>
           <a:prstGeom prst="ellipse">
@@ -2579,7 +2579,7 @@
         </p:nvSpPr>
         <p:spPr>
           <a:xfrm>
-            <a:off x="914400" y="3950208"/>
+            <a:off x="914400" y="4087368"/>
             <a:ext cx="384048" cy="384048"/>
           </a:xfrm>
           <a:prstGeom prst="rect">
@@ -2618,7 +2618,7 @@
         </p:nvSpPr>
         <p:spPr>
           <a:xfrm>
-            <a:off x="1481328" y="3895344"/>
+            <a:off x="1481328" y="4032504"/>
             <a:ext cx="5669280" cy="329184"/>
           </a:xfrm>
           <a:prstGeom prst="rect">
@@ -2657,7 +2657,7 @@
         </p:nvSpPr>
         <p:spPr>
           <a:xfrm>
-            <a:off x="1481328" y="4279392"/>
+            <a:off x="1481328" y="4416552"/>
             <a:ext cx="5669280" cy="731520"/>
           </a:xfrm>
           <a:prstGeom prst="rect">
@@ -2699,7 +2699,7 @@
         </p:nvSpPr>
         <p:spPr>
           <a:xfrm>
-            <a:off x="7818120" y="1874520"/>
+            <a:off x="7818120" y="2011680"/>
             <a:ext cx="3703320" cy="3246120"/>
           </a:xfrm>
           <a:prstGeom prst="roundRect">
@@ -2726,7 +2726,7 @@
         </p:nvSpPr>
         <p:spPr>
           <a:xfrm>
-            <a:off x="8092440" y="2148840"/>
+            <a:off x="8092440" y="2286000"/>
             <a:ext cx="3108960" cy="274320"/>
           </a:xfrm>
           <a:prstGeom prst="rect">
@@ -2765,7 +2765,7 @@
         </p:nvSpPr>
         <p:spPr>
           <a:xfrm>
-            <a:off x="8092440" y="2560320"/>
+            <a:off x="8092440" y="2697480"/>
             <a:ext cx="3200400" cy="1737360"/>
           </a:xfrm>
           <a:prstGeom prst="rect">
@@ -2867,7 +2867,7 @@
         </p:nvSpPr>
         <p:spPr>
           <a:xfrm>
-            <a:off x="8092440" y="4526280"/>
+            <a:off x="8092440" y="4663440"/>
             <a:ext cx="3200400" cy="365760"/>
           </a:xfrm>
           <a:prstGeom prst="rect">
@@ -2978,7 +2978,7 @@
         <p:spPr>
           <a:xfrm>
             <a:off x="640080" y="658368"/>
-            <a:ext cx="10881360" cy="914400"/>
+            <a:ext cx="10881360" cy="1280160"/>
           </a:xfrm>
           <a:prstGeom prst="rect">
             <a:avLst/>
@@ -3451,7 +3451,7 @@
         <p:spPr>
           <a:xfrm>
             <a:off x="640080" y="658368"/>
-            <a:ext cx="10881360" cy="914400"/>
+            <a:ext cx="10881360" cy="1280160"/>
           </a:xfrm>
           <a:prstGeom prst="rect">
             <a:avLst/>
@@ -3475,7 +3475,7 @@
                 <a:ea typeface="Cambria" pitchFamily="34" charset="-122"/>
                 <a:cs typeface="Cambria" pitchFamily="34" charset="-120"/>
               </a:rPr>
-              <a:t>Read the contract. Judge the mail. Track the promises.</a:t>
+              <a:t>Read the contract. Judge the mail.</a:t>
             </a:r>
             <a:endParaRPr lang="en-US" sz="3800" dirty="0"/>
           </a:p>
@@ -4110,7 +4110,7 @@
         <p:spPr>
           <a:xfrm>
             <a:off x="640080" y="658368"/>
-            <a:ext cx="10881360" cy="914400"/>
+            <a:ext cx="10881360" cy="1280160"/>
           </a:xfrm>
           <a:prstGeom prst="rect">
             <a:avLst/>
@@ -4134,7 +4134,7 @@
                 <a:ea typeface="Cambria" pitchFamily="34" charset="-122"/>
                 <a:cs typeface="Cambria" pitchFamily="34" charset="-120"/>
               </a:rPr>
-              <a:t>It flagged the slip a week before the client did</a:t>
+              <a:t>It flagged the slip before the client did</a:t>
             </a:r>
             <a:endParaRPr lang="en-US" sz="3800" dirty="0"/>
           </a:p>
@@ -4662,7 +4662,7 @@
         <p:spPr>
           <a:xfrm>
             <a:off x="640080" y="658368"/>
-            <a:ext cx="10881360" cy="914400"/>
+            <a:ext cx="10881360" cy="1280160"/>
           </a:xfrm>
           <a:prstGeom prst="rect">
             <a:avLst/>
@@ -4686,7 +4686,7 @@
                 <a:ea typeface="Cambria" pitchFamily="34" charset="-122"/>
                 <a:cs typeface="Cambria" pitchFamily="34" charset="-120"/>
               </a:rPr>
-              <a:t>Four stages, and a rule about who decides what</a:t>
+              <a:t>Four stages, and who decides what</a:t>
             </a:r>
             <a:endParaRPr lang="en-US" sz="3800" dirty="0"/>
           </a:p>
@@ -5617,7 +5617,7 @@
         <p:spPr>
           <a:xfrm>
             <a:off x="640080" y="658368"/>
-            <a:ext cx="10881360" cy="914400"/>
+            <a:ext cx="10881360" cy="1280160"/>
           </a:xfrm>
           <a:prstGeom prst="rect">
             <a:avLst/>
@@ -6417,7 +6417,7 @@
         <p:spPr>
           <a:xfrm>
             <a:off x="640080" y="658368"/>
-            <a:ext cx="10881360" cy="914400"/>
+            <a:ext cx="10881360" cy="1280160"/>
           </a:xfrm>
           <a:prstGeom prst="rect">
             <a:avLst/>
@@ -6441,7 +6441,7 @@
                 <a:ea typeface="Cambria" pitchFamily="34" charset="-122"/>
                 <a:cs typeface="Cambria" pitchFamily="34" charset="-120"/>
               </a:rPr>
-              <a:t>Two unrelated contracts. No prompt changes.</a:t>
+              <a:t>Two contracts. No prompt changes.</a:t>
             </a:r>
             <a:endParaRPr lang="en-US" sz="3800" dirty="0"/>
           </a:p>
@@ -8438,7 +8438,7 @@
         <p:spPr>
           <a:xfrm>
             <a:off x="8887968" y="3346704"/>
-            <a:ext cx="2423160" cy="1828800"/>
+            <a:ext cx="2423160" cy="2103120"/>
           </a:xfrm>
           <a:prstGeom prst="rect">
             <a:avLst/>
@@ -8452,7 +8452,7 @@
           <a:p>
             <a:pPr indent="0" marL="0">
               <a:lnSpc>
-                <a:spcPts val="1600"/>
+                <a:spcPts val="1500"/>
               </a:lnSpc>
               <a:buNone/>
             </a:pPr>
@@ -8465,7 +8465,36 @@
                 <a:ea typeface="Calibri" pitchFamily="34" charset="-122"/>
                 <a:cs typeface="Calibri" pitchFamily="34" charset="-120"/>
               </a:rPr>
-              <a:t>The borderline message in each thread returns “unsure” — five consecutive runs each, temperature pinned. We first claimed this from a single run, then re-ran it and found it was not true yet.</a:t>
+              <a:t>The borderline message in each thread returns “unsure”. Five consecutive runs each, temperature pinned.</a:t>
+            </a:r>
+            <a:endParaRPr lang="en-US" sz="1150" dirty="0"/>
+          </a:p>
+          <a:p>
+            <a:pPr indent="0" marL="0">
+              <a:lnSpc>
+                <a:spcPts val="1500"/>
+              </a:lnSpc>
+              <a:buNone/>
+            </a:pPr>
+            <a:endParaRPr lang="en-US" sz="1150" dirty="0"/>
+          </a:p>
+          <a:p>
+            <a:pPr indent="0" marL="0">
+              <a:lnSpc>
+                <a:spcPts val="1500"/>
+              </a:lnSpc>
+              <a:buNone/>
+            </a:pPr>
+            <a:r>
+              <a:rPr lang="en-US" sz="1150" dirty="0">
+                <a:solidFill>
+                  <a:srgbClr val="CFC9F2"/>
+                </a:solidFill>
+                <a:latin typeface="Calibri" pitchFamily="34" charset="0"/>
+                <a:ea typeface="Calibri" pitchFamily="34" charset="-122"/>
+                <a:cs typeface="Calibri" pitchFamily="34" charset="-120"/>
+              </a:rPr>
+              <a:t>We first claimed this from one run. Re-running proved it wasn't true yet.</a:t>
             </a:r>
             <a:endParaRPr lang="en-US" sz="1150" dirty="0"/>
           </a:p>
@@ -8551,7 +8580,7 @@
         <p:spPr>
           <a:xfrm>
             <a:off x="640080" y="658368"/>
-            <a:ext cx="10881360" cy="914400"/>
+            <a:ext cx="10881360" cy="1280160"/>
           </a:xfrm>
           <a:prstGeom prst="rect">
             <a:avLst/>
@@ -9115,7 +9144,7 @@
                 <a:ea typeface="Calibri" pitchFamily="34" charset="-122"/>
                 <a:cs typeface="Calibri" pitchFamily="34" charset="-120"/>
               </a:rPr>
-              <a:t>We said the confidence band held, on one run. Re-running gave a different answer. A catch-all clause let the model be certain about anything, so nothing was ever ambiguous — the fix was a rule, not a retry.</a:t>
+              <a:t>We said the confidence band held. Re-running gave a different answer — a catch-all clause let the model be certain about anything.</a:t>
             </a:r>
             <a:endParaRPr lang="en-US" sz="1150" dirty="0"/>
           </a:p>
@@ -9156,8 +9185,8 @@
         </p:nvSpPr>
         <p:spPr>
           <a:xfrm>
-            <a:off x="8549640" y="2487168"/>
-            <a:ext cx="2743200" cy="777240"/>
+            <a:off x="8549640" y="2450592"/>
+            <a:ext cx="2743200" cy="914400"/>
           </a:xfrm>
           <a:prstGeom prst="rect">
             <a:avLst/>
@@ -9181,7 +9210,7 @@
                 <a:ea typeface="Calibri" pitchFamily="34" charset="-122"/>
                 <a:cs typeface="Calibri" pitchFamily="34" charset="-120"/>
               </a:rPr>
-              <a:t>67</a:t>
+              <a:t>77</a:t>
             </a:r>
             <a:endParaRPr lang="en-US" sz="5400" dirty="0"/>
           </a:p>

</xml_diff>

<commit_message>
docs: bring the README and deck up to what the system now does
Both described a system two features behind. The README gains the amendment
story — including the measurement that prompted asking acceptance as its own
question — and a section on the evaluation harness with the numbers it
reports and the bug it found that the unit tests could not.

The deck gains a slide on amendments, which is the strongest technical idea in
the project and went unmentioned. The pipeline slide came out to make room:
it had come to repeat the capability slide, and its two distinct ideas moved
to where they belong — deadline resolution beside the other limits enforced in
code, and the vague-promise case beside the ledger it illustrates.

The engineering slide now reports measured agreement rather than a test count.
A number from a harness answers a sceptical question; a number of tests does
not.

Co-Authored-By: Claude Opus 5 <noreply@anthropic.com>
</commit_message>
<xml_diff>
--- a/deck/chief-of-staff.pptx
+++ b/deck/chief-of-staff.pptx
@@ -1039,7 +1039,7 @@
           <a:p>
             <a:r>
               <a:rPr lang="en-US" dirty="0"/>
-              <a:t>Python, SQLite, FastAPI. Provider behind one interface: Gemini shipped, Ollama for local iteration, Anthropic supported.</a:t>
+              <a:t>The amendment records the condition they attached — start only after the Collections page. Agreeing on terms is not the same as agreeing, and dropping the terms overstates what was settled.</a:t>
             </a:r>
             <a:endParaRPr lang="en-US" dirty="0"/>
           </a:p>
@@ -3475,7 +3475,7 @@
                 <a:ea typeface="Cambria" pitchFamily="34" charset="-122"/>
                 <a:cs typeface="Cambria" pitchFamily="34" charset="-120"/>
               </a:rPr>
-              <a:t>Read the contract. Judge the mail.</a:t>
+              <a:t>Read it. Judge the mail. Track what changed.</a:t>
             </a:r>
             <a:endParaRPr lang="en-US" sz="3800" dirty="0"/>
           </a:p>
@@ -3489,12 +3489,12 @@
         </p:nvSpPr>
         <p:spPr>
           <a:xfrm>
-            <a:off x="640080" y="1965960"/>
-            <a:ext cx="3429000" cy="3200400"/>
+            <a:off x="640080" y="2057400"/>
+            <a:ext cx="2560320" cy="3154680"/>
           </a:xfrm>
           <a:prstGeom prst="roundRect">
             <a:avLst>
-              <a:gd name="adj" fmla="val 857"/>
+              <a:gd name="adj" fmla="val 1071"/>
             </a:avLst>
           </a:prstGeom>
           <a:solidFill>
@@ -3516,7 +3516,7 @@
         </p:nvSpPr>
         <p:spPr>
           <a:xfrm>
-            <a:off x="932688" y="2286000"/>
+            <a:off x="877824" y="2340864"/>
             <a:ext cx="384048" cy="384048"/>
           </a:xfrm>
           <a:prstGeom prst="ellipse">
@@ -3536,7 +3536,7 @@
         </p:nvSpPr>
         <p:spPr>
           <a:xfrm>
-            <a:off x="932688" y="2286000"/>
+            <a:off x="877824" y="2340864"/>
             <a:ext cx="384048" cy="384048"/>
           </a:xfrm>
           <a:prstGeom prst="rect">
@@ -3575,8 +3575,8 @@
         </p:nvSpPr>
         <p:spPr>
           <a:xfrm>
-            <a:off x="932688" y="2852928"/>
-            <a:ext cx="2834640" cy="640080"/>
+            <a:off x="877824" y="2871216"/>
+            <a:ext cx="2103120" cy="658368"/>
           </a:xfrm>
           <a:prstGeom prst="rect">
             <a:avLst/>
@@ -3590,12 +3590,12 @@
           <a:p>
             <a:pPr indent="0" marL="0">
               <a:lnSpc>
-                <a:spcPts val="2400"/>
+                <a:spcPts val="2100"/>
               </a:lnSpc>
               <a:buNone/>
             </a:pPr>
             <a:r>
-              <a:rPr lang="en-US" sz="1800" b="1" dirty="0">
+              <a:rPr lang="en-US" sz="1600" b="1" dirty="0">
                 <a:solidFill>
                   <a:srgbClr val="16171D"/>
                 </a:solidFill>
@@ -3605,7 +3605,7 @@
               </a:rPr>
               <a:t>Reads the agreement</a:t>
             </a:r>
-            <a:endParaRPr lang="en-US" sz="1800" dirty="0"/>
+            <a:endParaRPr lang="en-US" sz="1600" dirty="0"/>
           </a:p>
         </p:txBody>
       </p:sp>
@@ -3617,8 +3617,8 @@
         </p:nvSpPr>
         <p:spPr>
           <a:xfrm>
-            <a:off x="932688" y="3566160"/>
-            <a:ext cx="2834640" cy="1463040"/>
+            <a:off x="877824" y="3584448"/>
+            <a:ext cx="2121408" cy="1508760"/>
           </a:xfrm>
           <a:prstGeom prst="rect">
             <a:avLst/>
@@ -3632,12 +3632,12 @@
           <a:p>
             <a:pPr indent="0" marL="0">
               <a:lnSpc>
-                <a:spcPts val="1800"/>
+                <a:spcPts val="1600"/>
               </a:lnSpc>
               <a:buNone/>
             </a:pPr>
             <a:r>
-              <a:rPr lang="en-US" sz="1300" dirty="0">
+              <a:rPr lang="en-US" sz="1200" dirty="0">
                 <a:solidFill>
                   <a:srgbClr val="5B6072"/>
                 </a:solidFill>
@@ -3645,9 +3645,9 @@
                 <a:ea typeface="Calibri" pitchFamily="34" charset="-122"/>
                 <a:cs typeface="Calibri" pitchFamily="34" charset="-120"/>
               </a:rPr>
-              <a:t>Turns a signed contract into scope items, each carrying a span copied word for word. A quote that isn't in the document raises — it is never quietly dropped.</a:t>
-            </a:r>
-            <a:endParaRPr lang="en-US" sz="1300" dirty="0"/>
+              <a:t>Turns a signed contract into scope items, each carrying a span copied word for word. A quote that isn't in the document raises — never quietly dropped.</a:t>
+            </a:r>
+            <a:endParaRPr lang="en-US" sz="1200" dirty="0"/>
           </a:p>
         </p:txBody>
       </p:sp>
@@ -3659,12 +3659,12 @@
         </p:nvSpPr>
         <p:spPr>
           <a:xfrm>
-            <a:off x="4389120" y="1965960"/>
-            <a:ext cx="3429000" cy="3200400"/>
+            <a:off x="3456432" y="2057400"/>
+            <a:ext cx="2560320" cy="3154680"/>
           </a:xfrm>
           <a:prstGeom prst="roundRect">
             <a:avLst>
-              <a:gd name="adj" fmla="val 857"/>
+              <a:gd name="adj" fmla="val 1071"/>
             </a:avLst>
           </a:prstGeom>
           <a:solidFill>
@@ -3686,7 +3686,7 @@
         </p:nvSpPr>
         <p:spPr>
           <a:xfrm>
-            <a:off x="4681728" y="2286000"/>
+            <a:off x="3694176" y="2340864"/>
             <a:ext cx="384048" cy="384048"/>
           </a:xfrm>
           <a:prstGeom prst="ellipse">
@@ -3706,7 +3706,7 @@
         </p:nvSpPr>
         <p:spPr>
           <a:xfrm>
-            <a:off x="4681728" y="2286000"/>
+            <a:off x="3694176" y="2340864"/>
             <a:ext cx="384048" cy="384048"/>
           </a:xfrm>
           <a:prstGeom prst="rect">
@@ -3745,8 +3745,8 @@
         </p:nvSpPr>
         <p:spPr>
           <a:xfrm>
-            <a:off x="4681728" y="2852928"/>
-            <a:ext cx="2834640" cy="640080"/>
+            <a:off x="3694176" y="2871216"/>
+            <a:ext cx="2103120" cy="658368"/>
           </a:xfrm>
           <a:prstGeom prst="rect">
             <a:avLst/>
@@ -3760,12 +3760,12 @@
           <a:p>
             <a:pPr indent="0" marL="0">
               <a:lnSpc>
-                <a:spcPts val="2400"/>
+                <a:spcPts val="2100"/>
               </a:lnSpc>
               <a:buNone/>
             </a:pPr>
             <a:r>
-              <a:rPr lang="en-US" sz="1800" b="1" dirty="0">
+              <a:rPr lang="en-US" sz="1600" b="1" dirty="0">
                 <a:solidFill>
                   <a:srgbClr val="16171D"/>
                 </a:solidFill>
@@ -3775,7 +3775,7 @@
               </a:rPr>
               <a:t>Judges every message</a:t>
             </a:r>
-            <a:endParaRPr lang="en-US" sz="1800" dirty="0"/>
+            <a:endParaRPr lang="en-US" sz="1600" dirty="0"/>
           </a:p>
         </p:txBody>
       </p:sp>
@@ -3787,8 +3787,8 @@
         </p:nvSpPr>
         <p:spPr>
           <a:xfrm>
-            <a:off x="4681728" y="3566160"/>
-            <a:ext cx="2834640" cy="1463040"/>
+            <a:off x="3694176" y="3584448"/>
+            <a:ext cx="2121408" cy="1508760"/>
           </a:xfrm>
           <a:prstGeom prst="rect">
             <a:avLst/>
@@ -3802,12 +3802,12 @@
           <a:p>
             <a:pPr indent="0" marL="0">
               <a:lnSpc>
-                <a:spcPts val="1800"/>
+                <a:spcPts val="1600"/>
               </a:lnSpc>
               <a:buNone/>
             </a:pPr>
             <a:r>
-              <a:rPr lang="en-US" sz="1300" dirty="0">
+              <a:rPr lang="en-US" sz="1200" dirty="0">
                 <a:solidFill>
                   <a:srgbClr val="5B6072"/>
                 </a:solidFill>
@@ -3817,7 +3817,7 @@
               </a:rPr>
               <a:t>In scope, out of scope, a new commitment, or noise — with the clause that decides it and how sure it is.</a:t>
             </a:r>
-            <a:endParaRPr lang="en-US" sz="1300" dirty="0"/>
+            <a:endParaRPr lang="en-US" sz="1200" dirty="0"/>
           </a:p>
         </p:txBody>
       </p:sp>
@@ -3829,12 +3829,12 @@
         </p:nvSpPr>
         <p:spPr>
           <a:xfrm>
-            <a:off x="8138160" y="1965960"/>
-            <a:ext cx="3429000" cy="3200400"/>
+            <a:off x="6272784" y="2057400"/>
+            <a:ext cx="2560320" cy="3154680"/>
           </a:xfrm>
           <a:prstGeom prst="roundRect">
             <a:avLst>
-              <a:gd name="adj" fmla="val 857"/>
+              <a:gd name="adj" fmla="val 1071"/>
             </a:avLst>
           </a:prstGeom>
           <a:solidFill>
@@ -3856,7 +3856,7 @@
         </p:nvSpPr>
         <p:spPr>
           <a:xfrm>
-            <a:off x="8430768" y="2286000"/>
+            <a:off x="6510528" y="2340864"/>
             <a:ext cx="384048" cy="384048"/>
           </a:xfrm>
           <a:prstGeom prst="ellipse">
@@ -3876,7 +3876,7 @@
         </p:nvSpPr>
         <p:spPr>
           <a:xfrm>
-            <a:off x="8430768" y="2286000"/>
+            <a:off x="6510528" y="2340864"/>
             <a:ext cx="384048" cy="384048"/>
           </a:xfrm>
           <a:prstGeom prst="rect">
@@ -3915,8 +3915,8 @@
         </p:nvSpPr>
         <p:spPr>
           <a:xfrm>
-            <a:off x="8430768" y="2852928"/>
-            <a:ext cx="2834640" cy="640080"/>
+            <a:off x="6510528" y="2871216"/>
+            <a:ext cx="2103120" cy="658368"/>
           </a:xfrm>
           <a:prstGeom prst="rect">
             <a:avLst/>
@@ -3930,12 +3930,12 @@
           <a:p>
             <a:pPr indent="0" marL="0">
               <a:lnSpc>
-                <a:spcPts val="2400"/>
+                <a:spcPts val="2100"/>
               </a:lnSpc>
               <a:buNone/>
             </a:pPr>
             <a:r>
-              <a:rPr lang="en-US" sz="1800" b="1" dirty="0">
+              <a:rPr lang="en-US" sz="1600" b="1" dirty="0">
                 <a:solidFill>
                   <a:srgbClr val="16171D"/>
                 </a:solidFill>
@@ -3945,7 +3945,7 @@
               </a:rPr>
               <a:t>Keeps the ledger</a:t>
             </a:r>
-            <a:endParaRPr lang="en-US" sz="1800" dirty="0"/>
+            <a:endParaRPr lang="en-US" sz="1600" dirty="0"/>
           </a:p>
         </p:txBody>
       </p:sp>
@@ -3957,8 +3957,8 @@
         </p:nvSpPr>
         <p:spPr>
           <a:xfrm>
-            <a:off x="8430768" y="3566160"/>
-            <a:ext cx="2834640" cy="1463040"/>
+            <a:off x="6510528" y="3584448"/>
+            <a:ext cx="2121408" cy="1508760"/>
           </a:xfrm>
           <a:prstGeom prst="rect">
             <a:avLst/>
@@ -3972,12 +3972,12 @@
           <a:p>
             <a:pPr indent="0" marL="0">
               <a:lnSpc>
-                <a:spcPts val="1800"/>
+                <a:spcPts val="1600"/>
               </a:lnSpc>
               <a:buNone/>
             </a:pPr>
             <a:r>
-              <a:rPr lang="en-US" sz="1300" dirty="0">
+              <a:rPr lang="en-US" sz="1200" dirty="0">
                 <a:solidFill>
                   <a:srgbClr val="5B6072"/>
                 </a:solidFill>
@@ -3985,7 +3985,93 @@
                 <a:ea typeface="Calibri" pitchFamily="34" charset="-122"/>
                 <a:cs typeface="Calibri" pitchFamily="34" charset="-120"/>
               </a:rPr>
-              <a:t>Every promise you made, the words that set its deadline, and whether you kept it.</a:t>
+              <a:t>Every promise either side made, the words that set its deadline, and whether it was kept.</a:t>
+            </a:r>
+            <a:endParaRPr lang="en-US" sz="1200" dirty="0"/>
+          </a:p>
+        </p:txBody>
+      </p:sp>
+      <p:sp>
+        <p:nvSpPr>
+          <p:cNvPr id="19" name="Shape 17"/>
+          <p:cNvSpPr/>
+          <p:nvPr/>
+        </p:nvSpPr>
+        <p:spPr>
+          <a:xfrm>
+            <a:off x="9089136" y="2057400"/>
+            <a:ext cx="2560320" cy="3154680"/>
+          </a:xfrm>
+          <a:prstGeom prst="roundRect">
+            <a:avLst>
+              <a:gd name="adj" fmla="val 1071"/>
+            </a:avLst>
+          </a:prstGeom>
+          <a:solidFill>
+            <a:srgbClr val="FBFBFD"/>
+          </a:solidFill>
+          <a:ln w="12700">
+            <a:solidFill>
+              <a:srgbClr val="D6D9E3"/>
+            </a:solidFill>
+            <a:prstDash val="solid"/>
+          </a:ln>
+        </p:spPr>
+      </p:sp>
+      <p:sp>
+        <p:nvSpPr>
+          <p:cNvPr id="20" name="Shape 18"/>
+          <p:cNvSpPr/>
+          <p:nvPr/>
+        </p:nvSpPr>
+        <p:spPr>
+          <a:xfrm>
+            <a:off x="9326880" y="2340864"/>
+            <a:ext cx="384048" cy="384048"/>
+          </a:xfrm>
+          <a:prstGeom prst="ellipse">
+            <a:avLst/>
+          </a:prstGeom>
+          <a:solidFill>
+            <a:srgbClr val="4B3F9E"/>
+          </a:solidFill>
+          <a:ln/>
+        </p:spPr>
+      </p:sp>
+      <p:sp>
+        <p:nvSpPr>
+          <p:cNvPr id="21" name="Text 19"/>
+          <p:cNvSpPr/>
+          <p:nvPr/>
+        </p:nvSpPr>
+        <p:spPr>
+          <a:xfrm>
+            <a:off x="9326880" y="2340864"/>
+            <a:ext cx="384048" cy="384048"/>
+          </a:xfrm>
+          <a:prstGeom prst="rect">
+            <a:avLst/>
+          </a:prstGeom>
+          <a:noFill/>
+          <a:ln/>
+        </p:spPr>
+        <p:txBody>
+          <a:bodyPr wrap="square" lIns="0" tIns="0" rIns="0" bIns="0" rtlCol="0" anchor="ctr"/>
+          <a:lstStyle/>
+          <a:p>
+            <a:pPr algn="ctr" indent="0" marL="0">
+              <a:buNone/>
+            </a:pPr>
+            <a:r>
+              <a:rPr lang="en-US" sz="1300" b="1" dirty="0">
+                <a:solidFill>
+                  <a:srgbClr val="FFFFFF"/>
+                </a:solidFill>
+                <a:latin typeface="Courier New" pitchFamily="34" charset="0"/>
+                <a:ea typeface="Courier New" pitchFamily="34" charset="-122"/>
+                <a:cs typeface="Courier New" pitchFamily="34" charset="-120"/>
+              </a:rPr>
+              <a:t>4</a:t>
             </a:r>
             <a:endParaRPr lang="en-US" sz="1300" dirty="0"/>
           </a:p>
@@ -3993,13 +4079,97 @@
       </p:sp>
       <p:sp>
         <p:nvSpPr>
-          <p:cNvPr id="19" name="Text 17"/>
-          <p:cNvSpPr/>
-          <p:nvPr/>
-        </p:nvSpPr>
-        <p:spPr>
-          <a:xfrm>
-            <a:off x="640080" y="5486400"/>
+          <p:cNvPr id="22" name="Text 20"/>
+          <p:cNvSpPr/>
+          <p:nvPr/>
+        </p:nvSpPr>
+        <p:spPr>
+          <a:xfrm>
+            <a:off x="9326880" y="2871216"/>
+            <a:ext cx="2103120" cy="658368"/>
+          </a:xfrm>
+          <a:prstGeom prst="rect">
+            <a:avLst/>
+          </a:prstGeom>
+          <a:noFill/>
+          <a:ln/>
+        </p:spPr>
+        <p:txBody>
+          <a:bodyPr wrap="square" lIns="0" tIns="0" rIns="0" bIns="0" rtlCol="0" anchor="ctr"/>
+          <a:lstStyle/>
+          <a:p>
+            <a:pPr indent="0" marL="0">
+              <a:lnSpc>
+                <a:spcPts val="2100"/>
+              </a:lnSpc>
+              <a:buNone/>
+            </a:pPr>
+            <a:r>
+              <a:rPr lang="en-US" sz="1600" b="1" dirty="0">
+                <a:solidFill>
+                  <a:srgbClr val="16171D"/>
+                </a:solidFill>
+                <a:latin typeface="Calibri" pitchFamily="34" charset="0"/>
+                <a:ea typeface="Calibri" pitchFamily="34" charset="-122"/>
+                <a:cs typeface="Calibri" pitchFamily="34" charset="-120"/>
+              </a:rPr>
+              <a:t>Tracks what changed</a:t>
+            </a:r>
+            <a:endParaRPr lang="en-US" sz="1600" dirty="0"/>
+          </a:p>
+        </p:txBody>
+      </p:sp>
+      <p:sp>
+        <p:nvSpPr>
+          <p:cNvPr id="23" name="Text 21"/>
+          <p:cNvSpPr/>
+          <p:nvPr/>
+        </p:nvSpPr>
+        <p:spPr>
+          <a:xfrm>
+            <a:off x="9326880" y="3584448"/>
+            <a:ext cx="2121408" cy="1508760"/>
+          </a:xfrm>
+          <a:prstGeom prst="rect">
+            <a:avLst/>
+          </a:prstGeom>
+          <a:noFill/>
+          <a:ln/>
+        </p:spPr>
+        <p:txBody>
+          <a:bodyPr wrap="square" lIns="0" tIns="0" rIns="0" bIns="0" rtlCol="0" anchor="ctr"/>
+          <a:lstStyle/>
+          <a:p>
+            <a:pPr indent="0" marL="0">
+              <a:lnSpc>
+                <a:spcPts val="1600"/>
+              </a:lnSpc>
+              <a:buNone/>
+            </a:pPr>
+            <a:r>
+              <a:rPr lang="en-US" sz="1200" dirty="0">
+                <a:solidFill>
+                  <a:srgbClr val="5B6072"/>
+                </a:solidFill>
+                <a:latin typeface="Calibri" pitchFamily="34" charset="0"/>
+                <a:ea typeface="Calibri" pitchFamily="34" charset="-122"/>
+                <a:cs typeface="Calibri" pitchFamily="34" charset="-120"/>
+              </a:rPr>
+              <a:t>When the client agrees in writing to work the contract never covered, that agreement becomes scope — cited to their own words.</a:t>
+            </a:r>
+            <a:endParaRPr lang="en-US" sz="1200" dirty="0"/>
+          </a:p>
+        </p:txBody>
+      </p:sp>
+      <p:sp>
+        <p:nvSpPr>
+          <p:cNvPr id="24" name="Text 22"/>
+          <p:cNvSpPr/>
+          <p:nvPr/>
+        </p:nvSpPr>
+        <p:spPr>
+          <a:xfrm>
+            <a:off x="640080" y="5532120"/>
             <a:ext cx="10881360" cy="365760"/>
           </a:xfrm>
           <a:prstGeom prst="rect">
@@ -4582,6 +4752,48 @@
           </a:p>
         </p:txBody>
       </p:sp>
+      <p:sp>
+        <p:nvSpPr>
+          <p:cNvPr id="15" name="Text 13"/>
+          <p:cNvSpPr/>
+          <p:nvPr/>
+        </p:nvSpPr>
+        <p:spPr>
+          <a:xfrm>
+            <a:off x="640080" y="5806440"/>
+            <a:ext cx="10881360" cy="457200"/>
+          </a:xfrm>
+          <a:prstGeom prst="rect">
+            <a:avLst/>
+          </a:prstGeom>
+          <a:noFill/>
+          <a:ln/>
+        </p:spPr>
+        <p:txBody>
+          <a:bodyPr wrap="square" lIns="0" tIns="0" rIns="0" bIns="0" rtlCol="0" anchor="ctr"/>
+          <a:lstStyle/>
+          <a:p>
+            <a:pPr indent="0" marL="0">
+              <a:lnSpc>
+                <a:spcPts val="1700"/>
+              </a:lnSpc>
+              <a:buNone/>
+            </a:pPr>
+            <a:r>
+              <a:rPr lang="en-US" sz="1300" dirty="0">
+                <a:solidFill>
+                  <a:srgbClr val="5B6072"/>
+                </a:solidFill>
+                <a:latin typeface="Calibri" pitchFamily="34" charset="0"/>
+                <a:ea typeface="Calibri" pitchFamily="34" charset="-122"/>
+                <a:cs typeface="Calibri" pitchFamily="34" charset="-120"/>
+              </a:rPr>
+              <a:t>“Soon” is recorded too — no date, marked vague, quoting the word you actually used. That is the promise that goes missing.</a:t>
+            </a:r>
+            <a:endParaRPr lang="en-US" sz="1300" dirty="0"/>
+          </a:p>
+        </p:txBody>
+      </p:sp>
     </p:spTree>
   </p:cSld>
   <p:clrMapOvr>
@@ -4647,7 +4859,7 @@
                 <a:ea typeface="Courier New" pitchFamily="34" charset="-122"/>
                 <a:cs typeface="Courier New" pitchFamily="34" charset="-120"/>
               </a:rPr>
-              <a:t>HOW IT WORKS</a:t>
+              <a:t>WHAT HAPPENS AFTER THEY SAY YES</a:t>
             </a:r>
             <a:endParaRPr lang="en-US" sz="1100" dirty="0"/>
           </a:p>
@@ -4686,7 +4898,7 @@
                 <a:ea typeface="Cambria" pitchFamily="34" charset="-122"/>
                 <a:cs typeface="Cambria" pitchFamily="34" charset="-120"/>
               </a:rPr>
-              <a:t>Four stages, and who decides what</a:t>
+              <a:t>The contract does not stay signed</a:t>
             </a:r>
             <a:endParaRPr lang="en-US" sz="3800" dirty="0"/>
           </a:p>
@@ -4694,99 +4906,30 @@
       </p:sp>
       <p:sp>
         <p:nvSpPr>
-          <p:cNvPr id="4" name="Shape 2"/>
-          <p:cNvSpPr/>
-          <p:nvPr/>
-        </p:nvSpPr>
-        <p:spPr>
-          <a:xfrm>
-            <a:off x="640080" y="2011680"/>
-            <a:ext cx="2514600" cy="1783080"/>
-          </a:xfrm>
-          <a:prstGeom prst="roundRect">
-            <a:avLst>
-              <a:gd name="adj" fmla="val 1538"/>
-            </a:avLst>
-          </a:prstGeom>
-          <a:solidFill>
-            <a:srgbClr val="FBFBFD"/>
-          </a:solidFill>
-          <a:ln w="12700">
-            <a:solidFill>
-              <a:srgbClr val="D6D9E3"/>
-            </a:solidFill>
-            <a:prstDash val="solid"/>
-          </a:ln>
-        </p:spPr>
-      </p:sp>
-      <p:sp>
-        <p:nvSpPr>
-          <p:cNvPr id="5" name="Text 3"/>
-          <p:cNvSpPr/>
-          <p:nvPr/>
-        </p:nvSpPr>
-        <p:spPr>
-          <a:xfrm>
-            <a:off x="859536" y="2249424"/>
-            <a:ext cx="2103120" cy="274320"/>
-          </a:xfrm>
-          <a:prstGeom prst="rect">
-            <a:avLst/>
-          </a:prstGeom>
-          <a:noFill/>
-          <a:ln/>
-        </p:spPr>
-        <p:txBody>
-          <a:bodyPr wrap="square" lIns="0" tIns="0" rIns="0" bIns="0" rtlCol="0" anchor="ctr"/>
-          <a:lstStyle/>
-          <a:p>
-            <a:pPr indent="0" marL="0">
-              <a:buNone/>
-            </a:pPr>
-            <a:r>
-              <a:rPr lang="en-US" sz="1200" b="1" spc="120" kern="0" dirty="0">
-                <a:solidFill>
-                  <a:srgbClr val="4B3F9E"/>
-                </a:solidFill>
-                <a:latin typeface="Courier New" pitchFamily="34" charset="0"/>
-                <a:ea typeface="Courier New" pitchFamily="34" charset="-122"/>
-                <a:cs typeface="Courier New" pitchFamily="34" charset="-120"/>
-              </a:rPr>
-              <a:t>INGEST</a:t>
-            </a:r>
-            <a:endParaRPr lang="en-US" sz="1200" dirty="0"/>
-          </a:p>
-        </p:txBody>
-      </p:sp>
-      <p:sp>
-        <p:nvSpPr>
-          <p:cNvPr id="6" name="Text 4"/>
-          <p:cNvSpPr/>
-          <p:nvPr/>
-        </p:nvSpPr>
-        <p:spPr>
-          <a:xfrm>
-            <a:off x="859536" y="2633472"/>
-            <a:ext cx="2148840" cy="960120"/>
-          </a:xfrm>
-          <a:prstGeom prst="rect">
-            <a:avLst/>
-          </a:prstGeom>
-          <a:noFill/>
-          <a:ln/>
-        </p:spPr>
-        <p:txBody>
-          <a:bodyPr wrap="square" lIns="0" tIns="0" rIns="0" bIns="0" rtlCol="0" anchor="ctr"/>
-          <a:lstStyle/>
-          <a:p>
-            <a:pPr indent="0" marL="0">
-              <a:lnSpc>
-                <a:spcPts val="1700"/>
-              </a:lnSpc>
-              <a:buNone/>
-            </a:pPr>
-            <a:r>
-              <a:rPr lang="en-US" sz="1250" dirty="0">
+          <p:cNvPr id="4" name="Text 2"/>
+          <p:cNvSpPr/>
+          <p:nvPr/>
+        </p:nvSpPr>
+        <p:spPr>
+          <a:xfrm>
+            <a:off x="640080" y="1627632"/>
+            <a:ext cx="10881360" cy="365760"/>
+          </a:xfrm>
+          <a:prstGeom prst="rect">
+            <a:avLst/>
+          </a:prstGeom>
+          <a:noFill/>
+          <a:ln/>
+        </p:spPr>
+        <p:txBody>
+          <a:bodyPr wrap="square" lIns="0" tIns="0" rIns="0" bIns="0" rtlCol="0" anchor="ctr"/>
+          <a:lstStyle/>
+          <a:p>
+            <a:pPr indent="0" marL="0">
+              <a:buNone/>
+            </a:pPr>
+            <a:r>
+              <a:rPr lang="en-US" sz="1600" dirty="0">
                 <a:solidFill>
                   <a:srgbClr val="5B6072"/>
                 </a:solidFill>
@@ -4794,547 +4937,26 @@
                 <a:ea typeface="Calibri" pitchFamily="34" charset="-122"/>
                 <a:cs typeface="Calibri" pitchFamily="34" charset="-120"/>
               </a:rPr>
-              <a:t>Contract → scope items,</a:t>
-            </a:r>
-            <a:endParaRPr lang="en-US" sz="1250" dirty="0"/>
-          </a:p>
-          <a:p>
-            <a:pPr indent="0" marL="0">
-              <a:lnSpc>
-                <a:spcPts val="1700"/>
-              </a:lnSpc>
-              <a:buNone/>
-            </a:pPr>
-            <a:r>
-              <a:rPr lang="en-US" sz="1250" dirty="0">
-                <a:solidFill>
-                  <a:srgbClr val="5B6072"/>
-                </a:solidFill>
-                <a:latin typeface="Calibri" pitchFamily="34" charset="0"/>
-                <a:ea typeface="Calibri" pitchFamily="34" charset="-122"/>
-                <a:cs typeface="Calibri" pitchFamily="34" charset="-120"/>
-              </a:rPr>
-              <a:t>each with a verbatim span</a:t>
-            </a:r>
-            <a:endParaRPr lang="en-US" sz="1250" dirty="0"/>
-          </a:p>
-        </p:txBody>
-      </p:sp>
-      <p:sp>
-        <p:nvSpPr>
-          <p:cNvPr id="7" name="Text 5"/>
-          <p:cNvSpPr/>
-          <p:nvPr/>
-        </p:nvSpPr>
-        <p:spPr>
-          <a:xfrm>
-            <a:off x="3191256" y="2651760"/>
-            <a:ext cx="274320" cy="365760"/>
-          </a:xfrm>
-          <a:prstGeom prst="rect">
-            <a:avLst/>
-          </a:prstGeom>
-          <a:noFill/>
-          <a:ln/>
-        </p:spPr>
-        <p:txBody>
-          <a:bodyPr wrap="square" lIns="0" tIns="0" rIns="0" bIns="0" rtlCol="0" anchor="ctr"/>
-          <a:lstStyle/>
-          <a:p>
-            <a:pPr algn="ctr" indent="0" marL="0">
-              <a:buNone/>
-            </a:pPr>
-            <a:r>
-              <a:rPr lang="en-US" sz="1800" dirty="0">
-                <a:solidFill>
-                  <a:srgbClr val="4B3F9E"/>
-                </a:solidFill>
-                <a:latin typeface="Calibri" pitchFamily="34" charset="0"/>
-                <a:ea typeface="Calibri" pitchFamily="34" charset="-122"/>
-                <a:cs typeface="Calibri" pitchFamily="34" charset="-120"/>
-              </a:rPr>
-              <a:t>→</a:t>
-            </a:r>
-            <a:endParaRPr lang="en-US" sz="1800" dirty="0"/>
-          </a:p>
-        </p:txBody>
-      </p:sp>
-      <p:sp>
-        <p:nvSpPr>
-          <p:cNvPr id="8" name="Shape 6"/>
-          <p:cNvSpPr/>
-          <p:nvPr/>
-        </p:nvSpPr>
-        <p:spPr>
-          <a:xfrm>
-            <a:off x="3456432" y="2011680"/>
-            <a:ext cx="2514600" cy="1783080"/>
+              <a:t>Scope changes by email. A tool that keeps citing the original document is wrong a week later.</a:t>
+            </a:r>
+            <a:endParaRPr lang="en-US" sz="1600" dirty="0"/>
+          </a:p>
+        </p:txBody>
+      </p:sp>
+      <p:sp>
+        <p:nvSpPr>
+          <p:cNvPr id="5" name="Shape 3"/>
+          <p:cNvSpPr/>
+          <p:nvPr/>
+        </p:nvSpPr>
+        <p:spPr>
+          <a:xfrm>
+            <a:off x="640080" y="2194560"/>
+            <a:ext cx="6858000" cy="1024128"/>
           </a:xfrm>
           <a:prstGeom prst="roundRect">
             <a:avLst>
-              <a:gd name="adj" fmla="val 1538"/>
-            </a:avLst>
-          </a:prstGeom>
-          <a:solidFill>
-            <a:srgbClr val="FBFBFD"/>
-          </a:solidFill>
-          <a:ln w="12700">
-            <a:solidFill>
-              <a:srgbClr val="D6D9E3"/>
-            </a:solidFill>
-            <a:prstDash val="solid"/>
-          </a:ln>
-        </p:spPr>
-      </p:sp>
-      <p:sp>
-        <p:nvSpPr>
-          <p:cNvPr id="9" name="Text 7"/>
-          <p:cNvSpPr/>
-          <p:nvPr/>
-        </p:nvSpPr>
-        <p:spPr>
-          <a:xfrm>
-            <a:off x="3675888" y="2249424"/>
-            <a:ext cx="2103120" cy="274320"/>
-          </a:xfrm>
-          <a:prstGeom prst="rect">
-            <a:avLst/>
-          </a:prstGeom>
-          <a:noFill/>
-          <a:ln/>
-        </p:spPr>
-        <p:txBody>
-          <a:bodyPr wrap="square" lIns="0" tIns="0" rIns="0" bIns="0" rtlCol="0" anchor="ctr"/>
-          <a:lstStyle/>
-          <a:p>
-            <a:pPr indent="0" marL="0">
-              <a:buNone/>
-            </a:pPr>
-            <a:r>
-              <a:rPr lang="en-US" sz="1200" b="1" spc="120" kern="0" dirty="0">
-                <a:solidFill>
-                  <a:srgbClr val="4B3F9E"/>
-                </a:solidFill>
-                <a:latin typeface="Courier New" pitchFamily="34" charset="0"/>
-                <a:ea typeface="Courier New" pitchFamily="34" charset="-122"/>
-                <a:cs typeface="Courier New" pitchFamily="34" charset="-120"/>
-              </a:rPr>
-              <a:t>CLASSIFY</a:t>
-            </a:r>
-            <a:endParaRPr lang="en-US" sz="1200" dirty="0"/>
-          </a:p>
-        </p:txBody>
-      </p:sp>
-      <p:sp>
-        <p:nvSpPr>
-          <p:cNvPr id="10" name="Text 8"/>
-          <p:cNvSpPr/>
-          <p:nvPr/>
-        </p:nvSpPr>
-        <p:spPr>
-          <a:xfrm>
-            <a:off x="3675888" y="2633472"/>
-            <a:ext cx="2148840" cy="960120"/>
-          </a:xfrm>
-          <a:prstGeom prst="rect">
-            <a:avLst/>
-          </a:prstGeom>
-          <a:noFill/>
-          <a:ln/>
-        </p:spPr>
-        <p:txBody>
-          <a:bodyPr wrap="square" lIns="0" tIns="0" rIns="0" bIns="0" rtlCol="0" anchor="ctr"/>
-          <a:lstStyle/>
-          <a:p>
-            <a:pPr indent="0" marL="0">
-              <a:lnSpc>
-                <a:spcPts val="1700"/>
-              </a:lnSpc>
-              <a:buNone/>
-            </a:pPr>
-            <a:r>
-              <a:rPr lang="en-US" sz="1250" dirty="0">
-                <a:solidFill>
-                  <a:srgbClr val="5B6072"/>
-                </a:solidFill>
-                <a:latin typeface="Calibri" pitchFamily="34" charset="0"/>
-                <a:ea typeface="Calibri" pitchFamily="34" charset="-122"/>
-                <a:cs typeface="Calibri" pitchFamily="34" charset="-120"/>
-              </a:rPr>
-              <a:t>Message → verdict,</a:t>
-            </a:r>
-            <a:endParaRPr lang="en-US" sz="1250" dirty="0"/>
-          </a:p>
-          <a:p>
-            <a:pPr indent="0" marL="0">
-              <a:lnSpc>
-                <a:spcPts val="1700"/>
-              </a:lnSpc>
-              <a:buNone/>
-            </a:pPr>
-            <a:r>
-              <a:rPr lang="en-US" sz="1250" dirty="0">
-                <a:solidFill>
-                  <a:srgbClr val="5B6072"/>
-                </a:solidFill>
-                <a:latin typeface="Calibri" pitchFamily="34" charset="0"/>
-                <a:ea typeface="Calibri" pitchFamily="34" charset="-122"/>
-                <a:cs typeface="Calibri" pitchFamily="34" charset="-120"/>
-              </a:rPr>
-              <a:t>cited to a clause</a:t>
-            </a:r>
-            <a:endParaRPr lang="en-US" sz="1250" dirty="0"/>
-          </a:p>
-        </p:txBody>
-      </p:sp>
-      <p:sp>
-        <p:nvSpPr>
-          <p:cNvPr id="11" name="Text 9"/>
-          <p:cNvSpPr/>
-          <p:nvPr/>
-        </p:nvSpPr>
-        <p:spPr>
-          <a:xfrm>
-            <a:off x="6007608" y="2651760"/>
-            <a:ext cx="274320" cy="365760"/>
-          </a:xfrm>
-          <a:prstGeom prst="rect">
-            <a:avLst/>
-          </a:prstGeom>
-          <a:noFill/>
-          <a:ln/>
-        </p:spPr>
-        <p:txBody>
-          <a:bodyPr wrap="square" lIns="0" tIns="0" rIns="0" bIns="0" rtlCol="0" anchor="ctr"/>
-          <a:lstStyle/>
-          <a:p>
-            <a:pPr algn="ctr" indent="0" marL="0">
-              <a:buNone/>
-            </a:pPr>
-            <a:r>
-              <a:rPr lang="en-US" sz="1800" dirty="0">
-                <a:solidFill>
-                  <a:srgbClr val="4B3F9E"/>
-                </a:solidFill>
-                <a:latin typeface="Calibri" pitchFamily="34" charset="0"/>
-                <a:ea typeface="Calibri" pitchFamily="34" charset="-122"/>
-                <a:cs typeface="Calibri" pitchFamily="34" charset="-120"/>
-              </a:rPr>
-              <a:t>→</a:t>
-            </a:r>
-            <a:endParaRPr lang="en-US" sz="1800" dirty="0"/>
-          </a:p>
-        </p:txBody>
-      </p:sp>
-      <p:sp>
-        <p:nvSpPr>
-          <p:cNvPr id="12" name="Shape 10"/>
-          <p:cNvSpPr/>
-          <p:nvPr/>
-        </p:nvSpPr>
-        <p:spPr>
-          <a:xfrm>
-            <a:off x="6272784" y="2011680"/>
-            <a:ext cx="2514600" cy="1783080"/>
-          </a:xfrm>
-          <a:prstGeom prst="roundRect">
-            <a:avLst>
-              <a:gd name="adj" fmla="val 1538"/>
-            </a:avLst>
-          </a:prstGeom>
-          <a:solidFill>
-            <a:srgbClr val="FBFBFD"/>
-          </a:solidFill>
-          <a:ln w="12700">
-            <a:solidFill>
-              <a:srgbClr val="D6D9E3"/>
-            </a:solidFill>
-            <a:prstDash val="solid"/>
-          </a:ln>
-        </p:spPr>
-      </p:sp>
-      <p:sp>
-        <p:nvSpPr>
-          <p:cNvPr id="13" name="Text 11"/>
-          <p:cNvSpPr/>
-          <p:nvPr/>
-        </p:nvSpPr>
-        <p:spPr>
-          <a:xfrm>
-            <a:off x="6492240" y="2249424"/>
-            <a:ext cx="2103120" cy="274320"/>
-          </a:xfrm>
-          <a:prstGeom prst="rect">
-            <a:avLst/>
-          </a:prstGeom>
-          <a:noFill/>
-          <a:ln/>
-        </p:spPr>
-        <p:txBody>
-          <a:bodyPr wrap="square" lIns="0" tIns="0" rIns="0" bIns="0" rtlCol="0" anchor="ctr"/>
-          <a:lstStyle/>
-          <a:p>
-            <a:pPr indent="0" marL="0">
-              <a:buNone/>
-            </a:pPr>
-            <a:r>
-              <a:rPr lang="en-US" sz="1200" b="1" spc="120" kern="0" dirty="0">
-                <a:solidFill>
-                  <a:srgbClr val="4B3F9E"/>
-                </a:solidFill>
-                <a:latin typeface="Courier New" pitchFamily="34" charset="0"/>
-                <a:ea typeface="Courier New" pitchFamily="34" charset="-122"/>
-                <a:cs typeface="Courier New" pitchFamily="34" charset="-120"/>
-              </a:rPr>
-              <a:t>LEDGER</a:t>
-            </a:r>
-            <a:endParaRPr lang="en-US" sz="1200" dirty="0"/>
-          </a:p>
-        </p:txBody>
-      </p:sp>
-      <p:sp>
-        <p:nvSpPr>
-          <p:cNvPr id="14" name="Text 12"/>
-          <p:cNvSpPr/>
-          <p:nvPr/>
-        </p:nvSpPr>
-        <p:spPr>
-          <a:xfrm>
-            <a:off x="6492240" y="2633472"/>
-            <a:ext cx="2148840" cy="960120"/>
-          </a:xfrm>
-          <a:prstGeom prst="rect">
-            <a:avLst/>
-          </a:prstGeom>
-          <a:noFill/>
-          <a:ln/>
-        </p:spPr>
-        <p:txBody>
-          <a:bodyPr wrap="square" lIns="0" tIns="0" rIns="0" bIns="0" rtlCol="0" anchor="ctr"/>
-          <a:lstStyle/>
-          <a:p>
-            <a:pPr indent="0" marL="0">
-              <a:lnSpc>
-                <a:spcPts val="1700"/>
-              </a:lnSpc>
-              <a:buNone/>
-            </a:pPr>
-            <a:r>
-              <a:rPr lang="en-US" sz="1250" dirty="0">
-                <a:solidFill>
-                  <a:srgbClr val="5B6072"/>
-                </a:solidFill>
-                <a:latin typeface="Calibri" pitchFamily="34" charset="0"/>
-                <a:ea typeface="Calibri" pitchFamily="34" charset="-122"/>
-                <a:cs typeface="Calibri" pitchFamily="34" charset="-120"/>
-              </a:rPr>
-              <a:t>Copied words → dates,</a:t>
-            </a:r>
-            <a:endParaRPr lang="en-US" sz="1250" dirty="0"/>
-          </a:p>
-          <a:p>
-            <a:pPr indent="0" marL="0">
-              <a:lnSpc>
-                <a:spcPts val="1700"/>
-              </a:lnSpc>
-              <a:buNone/>
-            </a:pPr>
-            <a:r>
-              <a:rPr lang="en-US" sz="1250" dirty="0">
-                <a:solidFill>
-                  <a:srgbClr val="5B6072"/>
-                </a:solidFill>
-                <a:latin typeface="Calibri" pitchFamily="34" charset="0"/>
-                <a:ea typeface="Calibri" pitchFamily="34" charset="-122"/>
-                <a:cs typeface="Calibri" pitchFamily="34" charset="-120"/>
-              </a:rPr>
-              <a:t>resolved in code</a:t>
-            </a:r>
-            <a:endParaRPr lang="en-US" sz="1250" dirty="0"/>
-          </a:p>
-        </p:txBody>
-      </p:sp>
-      <p:sp>
-        <p:nvSpPr>
-          <p:cNvPr id="15" name="Text 13"/>
-          <p:cNvSpPr/>
-          <p:nvPr/>
-        </p:nvSpPr>
-        <p:spPr>
-          <a:xfrm>
-            <a:off x="8823960" y="2651760"/>
-            <a:ext cx="274320" cy="365760"/>
-          </a:xfrm>
-          <a:prstGeom prst="rect">
-            <a:avLst/>
-          </a:prstGeom>
-          <a:noFill/>
-          <a:ln/>
-        </p:spPr>
-        <p:txBody>
-          <a:bodyPr wrap="square" lIns="0" tIns="0" rIns="0" bIns="0" rtlCol="0" anchor="ctr"/>
-          <a:lstStyle/>
-          <a:p>
-            <a:pPr algn="ctr" indent="0" marL="0">
-              <a:buNone/>
-            </a:pPr>
-            <a:r>
-              <a:rPr lang="en-US" sz="1800" dirty="0">
-                <a:solidFill>
-                  <a:srgbClr val="4B3F9E"/>
-                </a:solidFill>
-                <a:latin typeface="Calibri" pitchFamily="34" charset="0"/>
-                <a:ea typeface="Calibri" pitchFamily="34" charset="-122"/>
-                <a:cs typeface="Calibri" pitchFamily="34" charset="-120"/>
-              </a:rPr>
-              <a:t>→</a:t>
-            </a:r>
-            <a:endParaRPr lang="en-US" sz="1800" dirty="0"/>
-          </a:p>
-        </p:txBody>
-      </p:sp>
-      <p:sp>
-        <p:nvSpPr>
-          <p:cNvPr id="16" name="Shape 14"/>
-          <p:cNvSpPr/>
-          <p:nvPr/>
-        </p:nvSpPr>
-        <p:spPr>
-          <a:xfrm>
-            <a:off x="9089136" y="2011680"/>
-            <a:ext cx="2514600" cy="1783080"/>
-          </a:xfrm>
-          <a:prstGeom prst="roundRect">
-            <a:avLst>
-              <a:gd name="adj" fmla="val 1538"/>
-            </a:avLst>
-          </a:prstGeom>
-          <a:solidFill>
-            <a:srgbClr val="FBFBFD"/>
-          </a:solidFill>
-          <a:ln w="12700">
-            <a:solidFill>
-              <a:srgbClr val="D6D9E3"/>
-            </a:solidFill>
-            <a:prstDash val="solid"/>
-          </a:ln>
-        </p:spPr>
-      </p:sp>
-      <p:sp>
-        <p:nvSpPr>
-          <p:cNvPr id="17" name="Text 15"/>
-          <p:cNvSpPr/>
-          <p:nvPr/>
-        </p:nvSpPr>
-        <p:spPr>
-          <a:xfrm>
-            <a:off x="9308592" y="2249424"/>
-            <a:ext cx="2103120" cy="274320"/>
-          </a:xfrm>
-          <a:prstGeom prst="rect">
-            <a:avLst/>
-          </a:prstGeom>
-          <a:noFill/>
-          <a:ln/>
-        </p:spPr>
-        <p:txBody>
-          <a:bodyPr wrap="square" lIns="0" tIns="0" rIns="0" bIns="0" rtlCol="0" anchor="ctr"/>
-          <a:lstStyle/>
-          <a:p>
-            <a:pPr indent="0" marL="0">
-              <a:buNone/>
-            </a:pPr>
-            <a:r>
-              <a:rPr lang="en-US" sz="1200" b="1" spc="120" kern="0" dirty="0">
-                <a:solidFill>
-                  <a:srgbClr val="4B3F9E"/>
-                </a:solidFill>
-                <a:latin typeface="Courier New" pitchFamily="34" charset="0"/>
-                <a:ea typeface="Courier New" pitchFamily="34" charset="-122"/>
-                <a:cs typeface="Courier New" pitchFamily="34" charset="-120"/>
-              </a:rPr>
-              <a:t>DRAFT</a:t>
-            </a:r>
-            <a:endParaRPr lang="en-US" sz="1200" dirty="0"/>
-          </a:p>
-        </p:txBody>
-      </p:sp>
-      <p:sp>
-        <p:nvSpPr>
-          <p:cNvPr id="18" name="Text 16"/>
-          <p:cNvSpPr/>
-          <p:nvPr/>
-        </p:nvSpPr>
-        <p:spPr>
-          <a:xfrm>
-            <a:off x="9308592" y="2633472"/>
-            <a:ext cx="2148840" cy="960120"/>
-          </a:xfrm>
-          <a:prstGeom prst="rect">
-            <a:avLst/>
-          </a:prstGeom>
-          <a:noFill/>
-          <a:ln/>
-        </p:spPr>
-        <p:txBody>
-          <a:bodyPr wrap="square" lIns="0" tIns="0" rIns="0" bIns="0" rtlCol="0" anchor="ctr"/>
-          <a:lstStyle/>
-          <a:p>
-            <a:pPr indent="0" marL="0">
-              <a:lnSpc>
-                <a:spcPts val="1700"/>
-              </a:lnSpc>
-              <a:buNone/>
-            </a:pPr>
-            <a:r>
-              <a:rPr lang="en-US" sz="1250" dirty="0">
-                <a:solidFill>
-                  <a:srgbClr val="5B6072"/>
-                </a:solidFill>
-                <a:latin typeface="Calibri" pitchFamily="34" charset="0"/>
-                <a:ea typeface="Calibri" pitchFamily="34" charset="-122"/>
-                <a:cs typeface="Calibri" pitchFamily="34" charset="-120"/>
-              </a:rPr>
-              <a:t>Proposal → your</a:t>
-            </a:r>
-            <a:endParaRPr lang="en-US" sz="1250" dirty="0"/>
-          </a:p>
-          <a:p>
-            <a:pPr indent="0" marL="0">
-              <a:lnSpc>
-                <a:spcPts val="1700"/>
-              </a:lnSpc>
-              <a:buNone/>
-            </a:pPr>
-            <a:r>
-              <a:rPr lang="en-US" sz="1250" dirty="0">
-                <a:solidFill>
-                  <a:srgbClr val="5B6072"/>
-                </a:solidFill>
-                <a:latin typeface="Calibri" pitchFamily="34" charset="0"/>
-                <a:ea typeface="Calibri" pitchFamily="34" charset="-122"/>
-                <a:cs typeface="Calibri" pitchFamily="34" charset="-120"/>
-              </a:rPr>
-              <a:t>approval. Never sent.</a:t>
-            </a:r>
-            <a:endParaRPr lang="en-US" sz="1250" dirty="0"/>
-          </a:p>
-        </p:txBody>
-      </p:sp>
-      <p:sp>
-        <p:nvSpPr>
-          <p:cNvPr id="19" name="Shape 17"/>
-          <p:cNvSpPr/>
-          <p:nvPr/>
-        </p:nvSpPr>
-        <p:spPr>
-          <a:xfrm>
-            <a:off x="640080" y="4114800"/>
-            <a:ext cx="5394960" cy="1691640"/>
-          </a:xfrm>
-          <a:prstGeom prst="roundRect">
-            <a:avLst>
-              <a:gd name="adj" fmla="val 1622"/>
+              <a:gd name="adj" fmla="val 2679"/>
             </a:avLst>
           </a:prstGeom>
           <a:solidFill>
@@ -5350,99 +4972,138 @@
       </p:sp>
       <p:sp>
         <p:nvSpPr>
-          <p:cNvPr id="20" name="Text 18"/>
-          <p:cNvSpPr/>
-          <p:nvPr/>
-        </p:nvSpPr>
-        <p:spPr>
-          <a:xfrm>
-            <a:off x="914400" y="4370832"/>
-            <a:ext cx="4846320" cy="310896"/>
-          </a:xfrm>
-          <a:prstGeom prst="rect">
-            <a:avLst/>
-          </a:prstGeom>
-          <a:noFill/>
-          <a:ln/>
-        </p:spPr>
-        <p:txBody>
-          <a:bodyPr wrap="square" lIns="0" tIns="0" rIns="0" bIns="0" rtlCol="0" anchor="ctr"/>
-          <a:lstStyle/>
-          <a:p>
-            <a:pPr indent="0" marL="0">
-              <a:buNone/>
-            </a:pPr>
-            <a:r>
-              <a:rPr lang="en-US" sz="1700" b="1" dirty="0">
+          <p:cNvPr id="6" name="Text 4"/>
+          <p:cNvSpPr/>
+          <p:nvPr/>
+        </p:nvSpPr>
+        <p:spPr>
+          <a:xfrm>
+            <a:off x="914400" y="2377440"/>
+            <a:ext cx="1005840" cy="256032"/>
+          </a:xfrm>
+          <a:prstGeom prst="rect">
+            <a:avLst/>
+          </a:prstGeom>
+          <a:noFill/>
+          <a:ln/>
+        </p:spPr>
+        <p:txBody>
+          <a:bodyPr wrap="square" lIns="0" tIns="0" rIns="0" bIns="0" rtlCol="0" anchor="ctr"/>
+          <a:lstStyle/>
+          <a:p>
+            <a:pPr indent="0" marL="0">
+              <a:buNone/>
+            </a:pPr>
+            <a:r>
+              <a:rPr lang="en-US" sz="1000" b="1" spc="110" kern="0" dirty="0">
+                <a:solidFill>
+                  <a:srgbClr val="B3341F"/>
+                </a:solidFill>
+                <a:latin typeface="Courier New" pitchFamily="34" charset="0"/>
+                <a:ea typeface="Courier New" pitchFamily="34" charset="-122"/>
+                <a:cs typeface="Courier New" pitchFamily="34" charset="-120"/>
+              </a:rPr>
+              <a:t>17 AUG</a:t>
+            </a:r>
+            <a:endParaRPr lang="en-US" sz="1000" dirty="0"/>
+          </a:p>
+        </p:txBody>
+      </p:sp>
+      <p:sp>
+        <p:nvSpPr>
+          <p:cNvPr id="7" name="Text 5"/>
+          <p:cNvSpPr/>
+          <p:nvPr/>
+        </p:nvSpPr>
+        <p:spPr>
+          <a:xfrm>
+            <a:off x="2011680" y="2331720"/>
+            <a:ext cx="5303520" cy="329184"/>
+          </a:xfrm>
+          <a:prstGeom prst="rect">
+            <a:avLst/>
+          </a:prstGeom>
+          <a:noFill/>
+          <a:ln/>
+        </p:spPr>
+        <p:txBody>
+          <a:bodyPr wrap="square" lIns="0" tIns="0" rIns="0" bIns="0" rtlCol="0" anchor="ctr"/>
+          <a:lstStyle/>
+          <a:p>
+            <a:pPr indent="0" marL="0">
+              <a:buNone/>
+            </a:pPr>
+            <a:r>
+              <a:rPr lang="en-US" sz="1500" i="1" dirty="0">
                 <a:solidFill>
                   <a:srgbClr val="16171D"/>
+                </a:solidFill>
+                <a:latin typeface="Cambria" pitchFamily="34" charset="0"/>
+                <a:ea typeface="Cambria" pitchFamily="34" charset="-122"/>
+                <a:cs typeface="Cambria" pitchFamily="34" charset="-120"/>
+              </a:rPr>
+              <a:t>“the whole site in Hindi”</a:t>
+            </a:r>
+            <a:endParaRPr lang="en-US" sz="1500" dirty="0"/>
+          </a:p>
+        </p:txBody>
+      </p:sp>
+      <p:sp>
+        <p:nvSpPr>
+          <p:cNvPr id="8" name="Text 6"/>
+          <p:cNvSpPr/>
+          <p:nvPr/>
+        </p:nvSpPr>
+        <p:spPr>
+          <a:xfrm>
+            <a:off x="2011680" y="2706624"/>
+            <a:ext cx="5349240" cy="402336"/>
+          </a:xfrm>
+          <a:prstGeom prst="rect">
+            <a:avLst/>
+          </a:prstGeom>
+          <a:noFill/>
+          <a:ln/>
+        </p:spPr>
+        <p:txBody>
+          <a:bodyPr wrap="square" lIns="0" tIns="0" rIns="0" bIns="0" rtlCol="0" anchor="ctr"/>
+          <a:lstStyle/>
+          <a:p>
+            <a:pPr indent="0" marL="0">
+              <a:lnSpc>
+                <a:spcPts val="1600"/>
+              </a:lnSpc>
+              <a:buNone/>
+            </a:pPr>
+            <a:r>
+              <a:rPr lang="en-US" sz="1200" dirty="0">
+                <a:solidFill>
+                  <a:srgbClr val="5B6072"/>
                 </a:solidFill>
                 <a:latin typeface="Calibri" pitchFamily="34" charset="0"/>
                 <a:ea typeface="Calibri" pitchFamily="34" charset="-122"/>
                 <a:cs typeface="Calibri" pitchFamily="34" charset="-120"/>
               </a:rPr>
-              <a:t>The model copies. The code decides.</a:t>
-            </a:r>
-            <a:endParaRPr lang="en-US" sz="1700" dirty="0"/>
-          </a:p>
-        </p:txBody>
-      </p:sp>
-      <p:sp>
-        <p:nvSpPr>
-          <p:cNvPr id="21" name="Text 19"/>
-          <p:cNvSpPr/>
-          <p:nvPr/>
-        </p:nvSpPr>
-        <p:spPr>
-          <a:xfrm>
-            <a:off x="914400" y="4754880"/>
-            <a:ext cx="4846320" cy="914400"/>
-          </a:xfrm>
-          <a:prstGeom prst="rect">
-            <a:avLst/>
-          </a:prstGeom>
-          <a:noFill/>
-          <a:ln/>
-        </p:spPr>
-        <p:txBody>
-          <a:bodyPr wrap="square" lIns="0" tIns="0" rIns="0" bIns="0" rtlCol="0" anchor="ctr"/>
-          <a:lstStyle/>
-          <a:p>
-            <a:pPr indent="0" marL="0">
-              <a:lnSpc>
-                <a:spcPts val="1700"/>
-              </a:lnSpc>
-              <a:buNone/>
-            </a:pPr>
-            <a:r>
-              <a:rPr lang="en-US" sz="1250" dirty="0">
-                <a:solidFill>
-                  <a:srgbClr val="5B6072"/>
-                </a:solidFill>
-                <a:latin typeface="Calibri" pitchFamily="34" charset="0"/>
-                <a:ea typeface="Calibri" pitchFamily="34" charset="-122"/>
-                <a:cs typeface="Calibri" pitchFamily="34" charset="-120"/>
-              </a:rPr>
-              <a:t>It copies “by Friday” verbatim. Code anchors that to when the message arrived, in the freelancer's timezone. A model asked for a date invents a plausible one.</a:t>
-            </a:r>
-            <a:endParaRPr lang="en-US" sz="1250" dirty="0"/>
-          </a:p>
-        </p:txBody>
-      </p:sp>
-      <p:sp>
-        <p:nvSpPr>
-          <p:cNvPr id="22" name="Shape 20"/>
-          <p:cNvSpPr/>
-          <p:nvPr/>
-        </p:nvSpPr>
-        <p:spPr>
-          <a:xfrm>
-            <a:off x="6309360" y="4114800"/>
-            <a:ext cx="5212080" cy="1691640"/>
+              <a:t>Out of scope — the contract excludes translation.</a:t>
+            </a:r>
+            <a:endParaRPr lang="en-US" sz="1200" dirty="0"/>
+          </a:p>
+        </p:txBody>
+      </p:sp>
+      <p:sp>
+        <p:nvSpPr>
+          <p:cNvPr id="9" name="Shape 7"/>
+          <p:cNvSpPr/>
+          <p:nvPr/>
+        </p:nvSpPr>
+        <p:spPr>
+          <a:xfrm>
+            <a:off x="640080" y="3401568"/>
+            <a:ext cx="6858000" cy="1024128"/>
           </a:xfrm>
           <a:prstGeom prst="roundRect">
             <a:avLst>
-              <a:gd name="adj" fmla="val 1622"/>
+              <a:gd name="adj" fmla="val 2679"/>
             </a:avLst>
           </a:prstGeom>
           <a:solidFill>
@@ -5458,53 +5119,239 @@
       </p:sp>
       <p:sp>
         <p:nvSpPr>
-          <p:cNvPr id="23" name="Text 21"/>
-          <p:cNvSpPr/>
-          <p:nvPr/>
-        </p:nvSpPr>
-        <p:spPr>
-          <a:xfrm>
-            <a:off x="6583680" y="4370832"/>
-            <a:ext cx="4663440" cy="310896"/>
-          </a:xfrm>
-          <a:prstGeom prst="rect">
-            <a:avLst/>
-          </a:prstGeom>
-          <a:noFill/>
-          <a:ln/>
-        </p:spPr>
-        <p:txBody>
-          <a:bodyPr wrap="square" lIns="0" tIns="0" rIns="0" bIns="0" rtlCol="0" anchor="ctr"/>
-          <a:lstStyle/>
-          <a:p>
-            <a:pPr indent="0" marL="0">
-              <a:buNone/>
-            </a:pPr>
-            <a:r>
-              <a:rPr lang="en-US" sz="1700" b="1" dirty="0">
+          <p:cNvPr id="10" name="Text 8"/>
+          <p:cNvSpPr/>
+          <p:nvPr/>
+        </p:nvSpPr>
+        <p:spPr>
+          <a:xfrm>
+            <a:off x="914400" y="3584448"/>
+            <a:ext cx="1005840" cy="256032"/>
+          </a:xfrm>
+          <a:prstGeom prst="rect">
+            <a:avLst/>
+          </a:prstGeom>
+          <a:noFill/>
+          <a:ln/>
+        </p:spPr>
+        <p:txBody>
+          <a:bodyPr wrap="square" lIns="0" tIns="0" rIns="0" bIns="0" rtlCol="0" anchor="ctr"/>
+          <a:lstStyle/>
+          <a:p>
+            <a:pPr indent="0" marL="0">
+              <a:buNone/>
+            </a:pPr>
+            <a:r>
+              <a:rPr lang="en-US" sz="1000" b="1" spc="110" kern="0" dirty="0">
+                <a:solidFill>
+                  <a:srgbClr val="2F6B4F"/>
+                </a:solidFill>
+                <a:latin typeface="Courier New" pitchFamily="34" charset="0"/>
+                <a:ea typeface="Courier New" pitchFamily="34" charset="-122"/>
+                <a:cs typeface="Courier New" pitchFamily="34" charset="-120"/>
+              </a:rPr>
+              <a:t>26 AUG</a:t>
+            </a:r>
+            <a:endParaRPr lang="en-US" sz="1000" dirty="0"/>
+          </a:p>
+        </p:txBody>
+      </p:sp>
+      <p:sp>
+        <p:nvSpPr>
+          <p:cNvPr id="11" name="Text 9"/>
+          <p:cNvSpPr/>
+          <p:nvPr/>
+        </p:nvSpPr>
+        <p:spPr>
+          <a:xfrm>
+            <a:off x="2011680" y="3538728"/>
+            <a:ext cx="5303520" cy="329184"/>
+          </a:xfrm>
+          <a:prstGeom prst="rect">
+            <a:avLst/>
+          </a:prstGeom>
+          <a:noFill/>
+          <a:ln/>
+        </p:spPr>
+        <p:txBody>
+          <a:bodyPr wrap="square" lIns="0" tIns="0" rIns="0" bIns="0" rtlCol="0" anchor="ctr"/>
+          <a:lstStyle/>
+          <a:p>
+            <a:pPr indent="0" marL="0">
+              <a:buNone/>
+            </a:pPr>
+            <a:r>
+              <a:rPr lang="en-US" sz="1500" i="1" dirty="0">
                 <a:solidFill>
                   <a:srgbClr val="16171D"/>
+                </a:solidFill>
+                <a:latin typeface="Cambria" pitchFamily="34" charset="0"/>
+                <a:ea typeface="Cambria" pitchFamily="34" charset="-122"/>
+                <a:cs typeface="Cambria" pitchFamily="34" charset="-120"/>
+              </a:rPr>
+              <a:t>“we're happy to go ahead at INR 18,000”</a:t>
+            </a:r>
+            <a:endParaRPr lang="en-US" sz="1500" dirty="0"/>
+          </a:p>
+        </p:txBody>
+      </p:sp>
+      <p:sp>
+        <p:nvSpPr>
+          <p:cNvPr id="12" name="Text 10"/>
+          <p:cNvSpPr/>
+          <p:nvPr/>
+        </p:nvSpPr>
+        <p:spPr>
+          <a:xfrm>
+            <a:off x="2011680" y="3913632"/>
+            <a:ext cx="5349240" cy="402336"/>
+          </a:xfrm>
+          <a:prstGeom prst="rect">
+            <a:avLst/>
+          </a:prstGeom>
+          <a:noFill/>
+          <a:ln/>
+        </p:spPr>
+        <p:txBody>
+          <a:bodyPr wrap="square" lIns="0" tIns="0" rIns="0" bIns="0" rtlCol="0" anchor="ctr"/>
+          <a:lstStyle/>
+          <a:p>
+            <a:pPr indent="0" marL="0">
+              <a:lnSpc>
+                <a:spcPts val="1600"/>
+              </a:lnSpc>
+              <a:buNone/>
+            </a:pPr>
+            <a:r>
+              <a:rPr lang="en-US" sz="1200" dirty="0">
+                <a:solidFill>
+                  <a:srgbClr val="5B6072"/>
                 </a:solidFill>
                 <a:latin typeface="Calibri" pitchFamily="34" charset="0"/>
                 <a:ea typeface="Calibri" pitchFamily="34" charset="-122"/>
                 <a:cs typeface="Calibri" pitchFamily="34" charset="-120"/>
               </a:rPr>
-              <a:t>“Soon” is recorded, not discarded.</a:t>
-            </a:r>
-            <a:endParaRPr lang="en-US" sz="1700" dirty="0"/>
-          </a:p>
-        </p:txBody>
-      </p:sp>
-      <p:sp>
-        <p:nvSpPr>
-          <p:cNvPr id="24" name="Text 22"/>
-          <p:cNvSpPr/>
-          <p:nvPr/>
-        </p:nvSpPr>
-        <p:spPr>
-          <a:xfrm>
-            <a:off x="6583680" y="4754880"/>
-            <a:ext cx="4663440" cy="914400"/>
+              <a:t>Scope changes here. Their words become a clause.</a:t>
+            </a:r>
+            <a:endParaRPr lang="en-US" sz="1200" dirty="0"/>
+          </a:p>
+        </p:txBody>
+      </p:sp>
+      <p:sp>
+        <p:nvSpPr>
+          <p:cNvPr id="13" name="Shape 11"/>
+          <p:cNvSpPr/>
+          <p:nvPr/>
+        </p:nvSpPr>
+        <p:spPr>
+          <a:xfrm>
+            <a:off x="640080" y="4608576"/>
+            <a:ext cx="6858000" cy="1024128"/>
+          </a:xfrm>
+          <a:prstGeom prst="roundRect">
+            <a:avLst>
+              <a:gd name="adj" fmla="val 2679"/>
+            </a:avLst>
+          </a:prstGeom>
+          <a:solidFill>
+            <a:srgbClr val="FFFFFF"/>
+          </a:solidFill>
+          <a:ln w="12700">
+            <a:solidFill>
+              <a:srgbClr val="D6D9E3"/>
+            </a:solidFill>
+            <a:prstDash val="solid"/>
+          </a:ln>
+        </p:spPr>
+      </p:sp>
+      <p:sp>
+        <p:nvSpPr>
+          <p:cNvPr id="14" name="Text 12"/>
+          <p:cNvSpPr/>
+          <p:nvPr/>
+        </p:nvSpPr>
+        <p:spPr>
+          <a:xfrm>
+            <a:off x="914400" y="4791456"/>
+            <a:ext cx="1005840" cy="256032"/>
+          </a:xfrm>
+          <a:prstGeom prst="rect">
+            <a:avLst/>
+          </a:prstGeom>
+          <a:noFill/>
+          <a:ln/>
+        </p:spPr>
+        <p:txBody>
+          <a:bodyPr wrap="square" lIns="0" tIns="0" rIns="0" bIns="0" rtlCol="0" anchor="ctr"/>
+          <a:lstStyle/>
+          <a:p>
+            <a:pPr indent="0" marL="0">
+              <a:buNone/>
+            </a:pPr>
+            <a:r>
+              <a:rPr lang="en-US" sz="1000" b="1" spc="110" kern="0" dirty="0">
+                <a:solidFill>
+                  <a:srgbClr val="2F6B4F"/>
+                </a:solidFill>
+                <a:latin typeface="Courier New" pitchFamily="34" charset="0"/>
+                <a:ea typeface="Courier New" pitchFamily="34" charset="-122"/>
+                <a:cs typeface="Courier New" pitchFamily="34" charset="-120"/>
+              </a:rPr>
+              <a:t>27 AUG</a:t>
+            </a:r>
+            <a:endParaRPr lang="en-US" sz="1000" dirty="0"/>
+          </a:p>
+        </p:txBody>
+      </p:sp>
+      <p:sp>
+        <p:nvSpPr>
+          <p:cNvPr id="15" name="Text 13"/>
+          <p:cNvSpPr/>
+          <p:nvPr/>
+        </p:nvSpPr>
+        <p:spPr>
+          <a:xfrm>
+            <a:off x="2011680" y="4745736"/>
+            <a:ext cx="5303520" cy="329184"/>
+          </a:xfrm>
+          <a:prstGeom prst="rect">
+            <a:avLst/>
+          </a:prstGeom>
+          <a:noFill/>
+          <a:ln/>
+        </p:spPr>
+        <p:txBody>
+          <a:bodyPr wrap="square" lIns="0" tIns="0" rIns="0" bIns="0" rtlCol="0" anchor="ctr"/>
+          <a:lstStyle/>
+          <a:p>
+            <a:pPr indent="0" marL="0">
+              <a:buNone/>
+            </a:pPr>
+            <a:r>
+              <a:rPr lang="en-US" sz="1500" i="1" dirty="0">
+                <a:solidFill>
+                  <a:srgbClr val="16171D"/>
+                </a:solidFill>
+                <a:latin typeface="Cambria" pitchFamily="34" charset="0"/>
+                <a:ea typeface="Cambria" pitchFamily="34" charset="-122"/>
+                <a:cs typeface="Cambria" pitchFamily="34" charset="-120"/>
+              </a:rPr>
+              <a:t>“can Hindi prices use Devanagari numerals?”</a:t>
+            </a:r>
+            <a:endParaRPr lang="en-US" sz="1500" dirty="0"/>
+          </a:p>
+        </p:txBody>
+      </p:sp>
+      <p:sp>
+        <p:nvSpPr>
+          <p:cNvPr id="16" name="Text 14"/>
+          <p:cNvSpPr/>
+          <p:nvPr/>
+        </p:nvSpPr>
+        <p:spPr>
+          <a:xfrm>
+            <a:off x="2011680" y="5120640"/>
+            <a:ext cx="5349240" cy="402336"/>
           </a:xfrm>
           <a:prstGeom prst="rect">
             <a:avLst/>
@@ -5518,12 +5365,12 @@
           <a:p>
             <a:pPr indent="0" marL="0">
               <a:lnSpc>
-                <a:spcPts val="1700"/>
+                <a:spcPts val="1600"/>
               </a:lnSpc>
               <a:buNone/>
             </a:pPr>
             <a:r>
-              <a:rPr lang="en-US" sz="1250" dirty="0">
+              <a:rPr lang="en-US" sz="1200" dirty="0">
                 <a:solidFill>
                   <a:srgbClr val="5B6072"/>
                 </a:solidFill>
@@ -5531,9 +5378,159 @@
                 <a:ea typeface="Calibri" pitchFamily="34" charset="-122"/>
                 <a:cs typeface="Calibri" pitchFamily="34" charset="-120"/>
               </a:rPr>
-              <a:t>A promise with no date is the one that goes missing. It is kept in the ledger, marked vague, quoting the word you actually used.</a:t>
-            </a:r>
-            <a:endParaRPr lang="en-US" sz="1250" dirty="0"/>
+              <a:t>In scope — under the amendment, not the contract.</a:t>
+            </a:r>
+            <a:endParaRPr lang="en-US" sz="1200" dirty="0"/>
+          </a:p>
+        </p:txBody>
+      </p:sp>
+      <p:sp>
+        <p:nvSpPr>
+          <p:cNvPr id="17" name="Shape 15"/>
+          <p:cNvSpPr/>
+          <p:nvPr/>
+        </p:nvSpPr>
+        <p:spPr>
+          <a:xfrm>
+            <a:off x="7863840" y="2194560"/>
+            <a:ext cx="3657600" cy="3621024"/>
+          </a:xfrm>
+          <a:prstGeom prst="roundRect">
+            <a:avLst>
+              <a:gd name="adj" fmla="val 758"/>
+            </a:avLst>
+          </a:prstGeom>
+          <a:solidFill>
+            <a:srgbClr val="2E2569"/>
+          </a:solidFill>
+          <a:ln w="12700">
+            <a:solidFill>
+              <a:srgbClr val="D6D9E3"/>
+            </a:solidFill>
+            <a:prstDash val="solid"/>
+          </a:ln>
+        </p:spPr>
+      </p:sp>
+      <p:sp>
+        <p:nvSpPr>
+          <p:cNvPr id="18" name="Text 16"/>
+          <p:cNvSpPr/>
+          <p:nvPr/>
+        </p:nvSpPr>
+        <p:spPr>
+          <a:xfrm>
+            <a:off x="8138160" y="2468880"/>
+            <a:ext cx="3108960" cy="256032"/>
+          </a:xfrm>
+          <a:prstGeom prst="rect">
+            <a:avLst/>
+          </a:prstGeom>
+          <a:noFill/>
+          <a:ln/>
+        </p:spPr>
+        <p:txBody>
+          <a:bodyPr wrap="square" lIns="0" tIns="0" rIns="0" bIns="0" rtlCol="0" anchor="ctr"/>
+          <a:lstStyle/>
+          <a:p>
+            <a:pPr indent="0" marL="0">
+              <a:buNone/>
+            </a:pPr>
+            <a:r>
+              <a:rPr lang="en-US" sz="1000" spc="130" kern="0" dirty="0">
+                <a:solidFill>
+                  <a:srgbClr val="A9A2D8"/>
+                </a:solidFill>
+                <a:latin typeface="Courier New" pitchFamily="34" charset="0"/>
+                <a:ea typeface="Courier New" pitchFamily="34" charset="-122"/>
+                <a:cs typeface="Courier New" pitchFamily="34" charset="-120"/>
+              </a:rPr>
+              <a:t>WHO MAY WIDEN SCOPE</a:t>
+            </a:r>
+            <a:endParaRPr lang="en-US" sz="1000" dirty="0"/>
+          </a:p>
+        </p:txBody>
+      </p:sp>
+      <p:sp>
+        <p:nvSpPr>
+          <p:cNvPr id="19" name="Text 17"/>
+          <p:cNvSpPr/>
+          <p:nvPr/>
+        </p:nvSpPr>
+        <p:spPr>
+          <a:xfrm>
+            <a:off x="8138160" y="2852928"/>
+            <a:ext cx="3154680" cy="868680"/>
+          </a:xfrm>
+          <a:prstGeom prst="rect">
+            <a:avLst/>
+          </a:prstGeom>
+          <a:noFill/>
+          <a:ln/>
+        </p:spPr>
+        <p:txBody>
+          <a:bodyPr wrap="square" lIns="0" tIns="0" rIns="0" bIns="0" rtlCol="0" anchor="ctr"/>
+          <a:lstStyle/>
+          <a:p>
+            <a:pPr indent="0" marL="0">
+              <a:lnSpc>
+                <a:spcPts val="2700"/>
+              </a:lnSpc>
+              <a:buNone/>
+            </a:pPr>
+            <a:r>
+              <a:rPr lang="en-US" sz="2100" dirty="0">
+                <a:solidFill>
+                  <a:srgbClr val="FFFFFF"/>
+                </a:solidFill>
+                <a:latin typeface="Cambria" pitchFamily="34" charset="0"/>
+                <a:ea typeface="Cambria" pitchFamily="34" charset="-122"/>
+                <a:cs typeface="Cambria" pitchFamily="34" charset="-120"/>
+              </a:rPr>
+              <a:t>Only the side that pays.</a:t>
+            </a:r>
+            <a:endParaRPr lang="en-US" sz="2100" dirty="0"/>
+          </a:p>
+        </p:txBody>
+      </p:sp>
+      <p:sp>
+        <p:nvSpPr>
+          <p:cNvPr id="20" name="Text 18"/>
+          <p:cNvSpPr/>
+          <p:nvPr/>
+        </p:nvSpPr>
+        <p:spPr>
+          <a:xfrm>
+            <a:off x="8138160" y="3858768"/>
+            <a:ext cx="3154680" cy="1828800"/>
+          </a:xfrm>
+          <a:prstGeom prst="rect">
+            <a:avLst/>
+          </a:prstGeom>
+          <a:noFill/>
+          <a:ln/>
+        </p:spPr>
+        <p:txBody>
+          <a:bodyPr wrap="square" lIns="0" tIns="0" rIns="0" bIns="0" rtlCol="0" anchor="ctr"/>
+          <a:lstStyle/>
+          <a:p>
+            <a:pPr indent="0" marL="0">
+              <a:lnSpc>
+                <a:spcPts val="1600"/>
+              </a:lnSpc>
+              <a:buNone/>
+            </a:pPr>
+            <a:r>
+              <a:rPr lang="en-US" sz="1200" dirty="0">
+                <a:solidFill>
+                  <a:srgbClr val="CFC9F2"/>
+                </a:solidFill>
+                <a:latin typeface="Calibri" pitchFamily="34" charset="0"/>
+                <a:ea typeface="Calibri" pitchFamily="34" charset="-122"/>
+                <a:cs typeface="Calibri" pitchFamily="34" charset="-120"/>
+              </a:rPr>
+              <a:t>A contractor writing “great, I'll start Monday” is enthusiasm, not agreement. That rule is in the code, because a model asked whether somebody agreed will find agreement in warmth.</a:t>
+            </a:r>
+            <a:endParaRPr lang="en-US" sz="1200" dirty="0"/>
           </a:p>
         </p:txBody>
       </p:sp>
@@ -5694,12 +5691,12 @@
         </p:nvSpPr>
         <p:spPr>
           <a:xfrm>
-            <a:off x="640080" y="2240280"/>
-            <a:ext cx="6949440" cy="1024128"/>
+            <a:off x="640080" y="2194560"/>
+            <a:ext cx="6949440" cy="841248"/>
           </a:xfrm>
           <a:prstGeom prst="roundRect">
             <a:avLst>
-              <a:gd name="adj" fmla="val 2679"/>
+              <a:gd name="adj" fmla="val 3261"/>
             </a:avLst>
           </a:prstGeom>
           <a:solidFill>
@@ -5721,7 +5718,7 @@
         </p:nvSpPr>
         <p:spPr>
           <a:xfrm>
-            <a:off x="914400" y="2551176"/>
+            <a:off x="914400" y="2432304"/>
             <a:ext cx="365760" cy="365760"/>
           </a:xfrm>
           <a:prstGeom prst="ellipse">
@@ -5741,7 +5738,7 @@
         </p:nvSpPr>
         <p:spPr>
           <a:xfrm>
-            <a:off x="914400" y="2551176"/>
+            <a:off x="914400" y="2432304"/>
             <a:ext cx="365760" cy="365760"/>
           </a:xfrm>
           <a:prstGeom prst="rect">
@@ -5780,24 +5777,24 @@
         </p:nvSpPr>
         <p:spPr>
           <a:xfrm>
-            <a:off x="1463040" y="2386584"/>
-            <a:ext cx="5852160" cy="292608"/>
-          </a:xfrm>
-          <a:prstGeom prst="rect">
-            <a:avLst/>
-          </a:prstGeom>
-          <a:noFill/>
-          <a:ln/>
-        </p:spPr>
-        <p:txBody>
-          <a:bodyPr wrap="square" lIns="0" tIns="0" rIns="0" bIns="0" rtlCol="0" anchor="ctr"/>
-          <a:lstStyle/>
-          <a:p>
-            <a:pPr indent="0" marL="0">
-              <a:buNone/>
-            </a:pPr>
-            <a:r>
-              <a:rPr lang="en-US" sz="1650" b="1" dirty="0">
+            <a:off x="1463040" y="2295144"/>
+            <a:ext cx="5852160" cy="274320"/>
+          </a:xfrm>
+          <a:prstGeom prst="rect">
+            <a:avLst/>
+          </a:prstGeom>
+          <a:noFill/>
+          <a:ln/>
+        </p:spPr>
+        <p:txBody>
+          <a:bodyPr wrap="square" lIns="0" tIns="0" rIns="0" bIns="0" rtlCol="0" anchor="ctr"/>
+          <a:lstStyle/>
+          <a:p>
+            <a:pPr indent="0" marL="0">
+              <a:buNone/>
+            </a:pPr>
+            <a:r>
+              <a:rPr lang="en-US" sz="1550" b="1" dirty="0">
                 <a:solidFill>
                   <a:srgbClr val="16171D"/>
                 </a:solidFill>
@@ -5807,7 +5804,7 @@
               </a:rPr>
               <a:t>Never sends</a:t>
             </a:r>
-            <a:endParaRPr lang="en-US" sz="1650" dirty="0"/>
+            <a:endParaRPr lang="en-US" sz="1550" dirty="0"/>
           </a:p>
         </p:txBody>
       </p:sp>
@@ -5819,8 +5816,8 @@
         </p:nvSpPr>
         <p:spPr>
           <a:xfrm>
-            <a:off x="1463040" y="2715768"/>
-            <a:ext cx="5943600" cy="475488"/>
+            <a:off x="1463040" y="2587752"/>
+            <a:ext cx="5943600" cy="402336"/>
           </a:xfrm>
           <a:prstGeom prst="rect">
             <a:avLst/>
@@ -5834,12 +5831,12 @@
           <a:p>
             <a:pPr indent="0" marL="0">
               <a:lnSpc>
-                <a:spcPts val="1600"/>
+                <a:spcPts val="1500"/>
               </a:lnSpc>
               <a:buNone/>
             </a:pPr>
             <a:r>
-              <a:rPr lang="en-US" sz="1200" dirty="0">
+              <a:rPr lang="en-US" sz="1150" dirty="0">
                 <a:solidFill>
                   <a:srgbClr val="5B6072"/>
                 </a:solidFill>
@@ -5849,7 +5846,7 @@
               </a:rPr>
               <a:t>Drafts are created and stop there. The Gmail scope would permit sending; the codebase has no send path, and a test asserts it.</a:t>
             </a:r>
-            <a:endParaRPr lang="en-US" sz="1200" dirty="0"/>
+            <a:endParaRPr lang="en-US" sz="1150" dirty="0"/>
           </a:p>
         </p:txBody>
       </p:sp>
@@ -5861,12 +5858,12 @@
         </p:nvSpPr>
         <p:spPr>
           <a:xfrm>
-            <a:off x="640080" y="3447288"/>
-            <a:ext cx="6949440" cy="1024128"/>
+            <a:off x="640080" y="3154680"/>
+            <a:ext cx="6949440" cy="841248"/>
           </a:xfrm>
           <a:prstGeom prst="roundRect">
             <a:avLst>
-              <a:gd name="adj" fmla="val 2679"/>
+              <a:gd name="adj" fmla="val 3261"/>
             </a:avLst>
           </a:prstGeom>
           <a:solidFill>
@@ -5888,7 +5885,7 @@
         </p:nvSpPr>
         <p:spPr>
           <a:xfrm>
-            <a:off x="914400" y="3758184"/>
+            <a:off x="914400" y="3392424"/>
             <a:ext cx="365760" cy="365760"/>
           </a:xfrm>
           <a:prstGeom prst="ellipse">
@@ -5908,7 +5905,7 @@
         </p:nvSpPr>
         <p:spPr>
           <a:xfrm>
-            <a:off x="914400" y="3758184"/>
+            <a:off x="914400" y="3392424"/>
             <a:ext cx="365760" cy="365760"/>
           </a:xfrm>
           <a:prstGeom prst="rect">
@@ -5947,24 +5944,24 @@
         </p:nvSpPr>
         <p:spPr>
           <a:xfrm>
-            <a:off x="1463040" y="3593592"/>
-            <a:ext cx="5852160" cy="292608"/>
-          </a:xfrm>
-          <a:prstGeom prst="rect">
-            <a:avLst/>
-          </a:prstGeom>
-          <a:noFill/>
-          <a:ln/>
-        </p:spPr>
-        <p:txBody>
-          <a:bodyPr wrap="square" lIns="0" tIns="0" rIns="0" bIns="0" rtlCol="0" anchor="ctr"/>
-          <a:lstStyle/>
-          <a:p>
-            <a:pPr indent="0" marL="0">
-              <a:buNone/>
-            </a:pPr>
-            <a:r>
-              <a:rPr lang="en-US" sz="1650" b="1" dirty="0">
+            <a:off x="1463040" y="3255264"/>
+            <a:ext cx="5852160" cy="274320"/>
+          </a:xfrm>
+          <a:prstGeom prst="rect">
+            <a:avLst/>
+          </a:prstGeom>
+          <a:noFill/>
+          <a:ln/>
+        </p:spPr>
+        <p:txBody>
+          <a:bodyPr wrap="square" lIns="0" tIns="0" rIns="0" bIns="0" rtlCol="0" anchor="ctr"/>
+          <a:lstStyle/>
+          <a:p>
+            <a:pPr indent="0" marL="0">
+              <a:buNone/>
+            </a:pPr>
+            <a:r>
+              <a:rPr lang="en-US" sz="1550" b="1" dirty="0">
                 <a:solidFill>
                   <a:srgbClr val="16171D"/>
                 </a:solidFill>
@@ -5974,7 +5971,7 @@
               </a:rPr>
               <a:t>Never invents money</a:t>
             </a:r>
-            <a:endParaRPr lang="en-US" sz="1650" dirty="0"/>
+            <a:endParaRPr lang="en-US" sz="1550" dirty="0"/>
           </a:p>
         </p:txBody>
       </p:sp>
@@ -5986,8 +5983,8 @@
         </p:nvSpPr>
         <p:spPr>
           <a:xfrm>
-            <a:off x="1463040" y="3922776"/>
-            <a:ext cx="5943600" cy="475488"/>
+            <a:off x="1463040" y="3547872"/>
+            <a:ext cx="5943600" cy="402336"/>
           </a:xfrm>
           <a:prstGeom prst="rect">
             <a:avLst/>
@@ -6001,12 +5998,12 @@
           <a:p>
             <a:pPr indent="0" marL="0">
               <a:lnSpc>
-                <a:spcPts val="1600"/>
+                <a:spcPts val="1500"/>
               </a:lnSpc>
               <a:buNone/>
             </a:pPr>
             <a:r>
-              <a:rPr lang="en-US" sz="1200" dirty="0">
+              <a:rPr lang="en-US" sz="1150" dirty="0">
                 <a:solidFill>
                   <a:srgbClr val="5B6072"/>
                 </a:solidFill>
@@ -6016,7 +6013,7 @@
               </a:rPr>
               <a:t>No fee or percentage may appear in a reply unless it is already in the contract.</a:t>
             </a:r>
-            <a:endParaRPr lang="en-US" sz="1200" dirty="0"/>
+            <a:endParaRPr lang="en-US" sz="1150" dirty="0"/>
           </a:p>
         </p:txBody>
       </p:sp>
@@ -6028,12 +6025,12 @@
         </p:nvSpPr>
         <p:spPr>
           <a:xfrm>
-            <a:off x="640080" y="4654296"/>
-            <a:ext cx="6949440" cy="1024128"/>
+            <a:off x="640080" y="4114800"/>
+            <a:ext cx="6949440" cy="841248"/>
           </a:xfrm>
           <a:prstGeom prst="roundRect">
             <a:avLst>
-              <a:gd name="adj" fmla="val 2679"/>
+              <a:gd name="adj" fmla="val 3261"/>
             </a:avLst>
           </a:prstGeom>
           <a:solidFill>
@@ -6055,7 +6052,7 @@
         </p:nvSpPr>
         <p:spPr>
           <a:xfrm>
-            <a:off x="914400" y="4965192"/>
+            <a:off x="914400" y="4352544"/>
             <a:ext cx="365760" cy="365760"/>
           </a:xfrm>
           <a:prstGeom prst="ellipse">
@@ -6075,7 +6072,7 @@
         </p:nvSpPr>
         <p:spPr>
           <a:xfrm>
-            <a:off x="914400" y="4965192"/>
+            <a:off x="914400" y="4352544"/>
             <a:ext cx="365760" cy="365760"/>
           </a:xfrm>
           <a:prstGeom prst="rect">
@@ -6114,24 +6111,24 @@
         </p:nvSpPr>
         <p:spPr>
           <a:xfrm>
-            <a:off x="1463040" y="4800600"/>
-            <a:ext cx="5852160" cy="292608"/>
-          </a:xfrm>
-          <a:prstGeom prst="rect">
-            <a:avLst/>
-          </a:prstGeom>
-          <a:noFill/>
-          <a:ln/>
-        </p:spPr>
-        <p:txBody>
-          <a:bodyPr wrap="square" lIns="0" tIns="0" rIns="0" bIns="0" rtlCol="0" anchor="ctr"/>
-          <a:lstStyle/>
-          <a:p>
-            <a:pPr indent="0" marL="0">
-              <a:buNone/>
-            </a:pPr>
-            <a:r>
-              <a:rPr lang="en-US" sz="1650" b="1" dirty="0">
+            <a:off x="1463040" y="4215384"/>
+            <a:ext cx="5852160" cy="274320"/>
+          </a:xfrm>
+          <a:prstGeom prst="rect">
+            <a:avLst/>
+          </a:prstGeom>
+          <a:noFill/>
+          <a:ln/>
+        </p:spPr>
+        <p:txBody>
+          <a:bodyPr wrap="square" lIns="0" tIns="0" rIns="0" bIns="0" rtlCol="0" anchor="ctr"/>
+          <a:lstStyle/>
+          <a:p>
+            <a:pPr indent="0" marL="0">
+              <a:buNone/>
+            </a:pPr>
+            <a:r>
+              <a:rPr lang="en-US" sz="1550" b="1" dirty="0">
                 <a:solidFill>
                   <a:srgbClr val="16171D"/>
                 </a:solidFill>
@@ -6141,7 +6138,7 @@
               </a:rPr>
               <a:t>Never picks your date</a:t>
             </a:r>
-            <a:endParaRPr lang="en-US" sz="1650" dirty="0"/>
+            <a:endParaRPr lang="en-US" sz="1550" dirty="0"/>
           </a:p>
         </p:txBody>
       </p:sp>
@@ -6153,8 +6150,8 @@
         </p:nvSpPr>
         <p:spPr>
           <a:xfrm>
-            <a:off x="1463040" y="5129784"/>
-            <a:ext cx="5943600" cy="475488"/>
+            <a:off x="1463040" y="4507992"/>
+            <a:ext cx="5943600" cy="402336"/>
           </a:xfrm>
           <a:prstGeom prst="rect">
             <a:avLst/>
@@ -6168,12 +6165,12 @@
           <a:p>
             <a:pPr indent="0" marL="0">
               <a:lnSpc>
-                <a:spcPts val="1600"/>
+                <a:spcPts val="1500"/>
               </a:lnSpc>
               <a:buNone/>
             </a:pPr>
             <a:r>
-              <a:rPr lang="en-US" sz="1200" dirty="0">
+              <a:rPr lang="en-US" sz="1150" dirty="0">
                 <a:solidFill>
                   <a:srgbClr val="5B6072"/>
                 </a:solidFill>
@@ -6183,7 +6180,7 @@
               </a:rPr>
               <a:t>A late-work update leaves [NEW DATE] for you. Committing you to a date you never agreed is not the agent's to do.</a:t>
             </a:r>
-            <a:endParaRPr lang="en-US" sz="1200" dirty="0"/>
+            <a:endParaRPr lang="en-US" sz="1150" dirty="0"/>
           </a:p>
         </p:txBody>
       </p:sp>
@@ -6195,12 +6192,179 @@
         </p:nvSpPr>
         <p:spPr>
           <a:xfrm>
-            <a:off x="7955280" y="2240280"/>
-            <a:ext cx="3566160" cy="3648456"/>
+            <a:off x="640080" y="5074920"/>
+            <a:ext cx="6949440" cy="841248"/>
           </a:xfrm>
           <a:prstGeom prst="roundRect">
             <a:avLst>
-              <a:gd name="adj" fmla="val 769"/>
+              <a:gd name="adj" fmla="val 3261"/>
+            </a:avLst>
+          </a:prstGeom>
+          <a:solidFill>
+            <a:srgbClr val="FFFFFF"/>
+          </a:solidFill>
+          <a:ln w="12700">
+            <a:solidFill>
+              <a:srgbClr val="D6D9E3"/>
+            </a:solidFill>
+            <a:prstDash val="solid"/>
+          </a:ln>
+        </p:spPr>
+      </p:sp>
+      <p:sp>
+        <p:nvSpPr>
+          <p:cNvPr id="21" name="Shape 19"/>
+          <p:cNvSpPr/>
+          <p:nvPr/>
+        </p:nvSpPr>
+        <p:spPr>
+          <a:xfrm>
+            <a:off x="914400" y="5312664"/>
+            <a:ext cx="365760" cy="365760"/>
+          </a:xfrm>
+          <a:prstGeom prst="ellipse">
+            <a:avLst/>
+          </a:prstGeom>
+          <a:solidFill>
+            <a:srgbClr val="B3341F"/>
+          </a:solidFill>
+          <a:ln/>
+        </p:spPr>
+      </p:sp>
+      <p:sp>
+        <p:nvSpPr>
+          <p:cNvPr id="22" name="Text 20"/>
+          <p:cNvSpPr/>
+          <p:nvPr/>
+        </p:nvSpPr>
+        <p:spPr>
+          <a:xfrm>
+            <a:off x="914400" y="5312664"/>
+            <a:ext cx="365760" cy="365760"/>
+          </a:xfrm>
+          <a:prstGeom prst="rect">
+            <a:avLst/>
+          </a:prstGeom>
+          <a:noFill/>
+          <a:ln/>
+        </p:spPr>
+        <p:txBody>
+          <a:bodyPr wrap="square" lIns="0" tIns="0" rIns="0" bIns="0" rtlCol="0" anchor="ctr"/>
+          <a:lstStyle/>
+          <a:p>
+            <a:pPr algn="ctr" indent="0" marL="0">
+              <a:buNone/>
+            </a:pPr>
+            <a:r>
+              <a:rPr lang="en-US" sz="1300" b="1" dirty="0">
+                <a:solidFill>
+                  <a:srgbClr val="FFFFFF"/>
+                </a:solidFill>
+                <a:latin typeface="Courier New" pitchFamily="34" charset="0"/>
+                <a:ea typeface="Courier New" pitchFamily="34" charset="-122"/>
+                <a:cs typeface="Courier New" pitchFamily="34" charset="-120"/>
+              </a:rPr>
+              <a:t>×</a:t>
+            </a:r>
+            <a:endParaRPr lang="en-US" sz="1300" dirty="0"/>
+          </a:p>
+        </p:txBody>
+      </p:sp>
+      <p:sp>
+        <p:nvSpPr>
+          <p:cNvPr id="23" name="Text 21"/>
+          <p:cNvSpPr/>
+          <p:nvPr/>
+        </p:nvSpPr>
+        <p:spPr>
+          <a:xfrm>
+            <a:off x="1463040" y="5175504"/>
+            <a:ext cx="5852160" cy="274320"/>
+          </a:xfrm>
+          <a:prstGeom prst="rect">
+            <a:avLst/>
+          </a:prstGeom>
+          <a:noFill/>
+          <a:ln/>
+        </p:spPr>
+        <p:txBody>
+          <a:bodyPr wrap="square" lIns="0" tIns="0" rIns="0" bIns="0" rtlCol="0" anchor="ctr"/>
+          <a:lstStyle/>
+          <a:p>
+            <a:pPr indent="0" marL="0">
+              <a:buNone/>
+            </a:pPr>
+            <a:r>
+              <a:rPr lang="en-US" sz="1550" b="1" dirty="0">
+                <a:solidFill>
+                  <a:srgbClr val="16171D"/>
+                </a:solidFill>
+                <a:latin typeface="Calibri" pitchFamily="34" charset="0"/>
+                <a:ea typeface="Calibri" pitchFamily="34" charset="-122"/>
+                <a:cs typeface="Calibri" pitchFamily="34" charset="-120"/>
+              </a:rPr>
+              <a:t>Never guesses a deadline</a:t>
+            </a:r>
+            <a:endParaRPr lang="en-US" sz="1550" dirty="0"/>
+          </a:p>
+        </p:txBody>
+      </p:sp>
+      <p:sp>
+        <p:nvSpPr>
+          <p:cNvPr id="24" name="Text 22"/>
+          <p:cNvSpPr/>
+          <p:nvPr/>
+        </p:nvSpPr>
+        <p:spPr>
+          <a:xfrm>
+            <a:off x="1463040" y="5468112"/>
+            <a:ext cx="5943600" cy="402336"/>
+          </a:xfrm>
+          <a:prstGeom prst="rect">
+            <a:avLst/>
+          </a:prstGeom>
+          <a:noFill/>
+          <a:ln/>
+        </p:spPr>
+        <p:txBody>
+          <a:bodyPr wrap="square" lIns="0" tIns="0" rIns="0" bIns="0" rtlCol="0" anchor="ctr"/>
+          <a:lstStyle/>
+          <a:p>
+            <a:pPr indent="0" marL="0">
+              <a:lnSpc>
+                <a:spcPts val="1500"/>
+              </a:lnSpc>
+              <a:buNone/>
+            </a:pPr>
+            <a:r>
+              <a:rPr lang="en-US" sz="1150" dirty="0">
+                <a:solidFill>
+                  <a:srgbClr val="5B6072"/>
+                </a:solidFill>
+                <a:latin typeface="Calibri" pitchFamily="34" charset="0"/>
+                <a:ea typeface="Calibri" pitchFamily="34" charset="-122"/>
+                <a:cs typeface="Calibri" pitchFamily="34" charset="-120"/>
+              </a:rPr>
+              <a:t>It copies “by Friday” verbatim; code turns that into a date in your timezone. A model asked for a date invents a plausible one.</a:t>
+            </a:r>
+            <a:endParaRPr lang="en-US" sz="1150" dirty="0"/>
+          </a:p>
+        </p:txBody>
+      </p:sp>
+      <p:sp>
+        <p:nvSpPr>
+          <p:cNvPr id="25" name="Shape 23"/>
+          <p:cNvSpPr/>
+          <p:nvPr/>
+        </p:nvSpPr>
+        <p:spPr>
+          <a:xfrm>
+            <a:off x="7955280" y="2194560"/>
+            <a:ext cx="3566160" cy="3520440"/>
+          </a:xfrm>
+          <a:prstGeom prst="roundRect">
+            <a:avLst>
+              <a:gd name="adj" fmla="val 779"/>
             </a:avLst>
           </a:prstGeom>
           <a:solidFill>
@@ -6216,13 +6380,13 @@
       </p:sp>
       <p:sp>
         <p:nvSpPr>
-          <p:cNvPr id="21" name="Text 19"/>
-          <p:cNvSpPr/>
-          <p:nvPr/>
-        </p:nvSpPr>
-        <p:spPr>
-          <a:xfrm>
-            <a:off x="8229600" y="2514600"/>
+          <p:cNvPr id="26" name="Text 24"/>
+          <p:cNvSpPr/>
+          <p:nvPr/>
+        </p:nvSpPr>
+        <p:spPr>
+          <a:xfrm>
+            <a:off x="8229600" y="2468880"/>
             <a:ext cx="3017520" cy="256032"/>
           </a:xfrm>
           <a:prstGeom prst="rect">
@@ -6255,7 +6419,7 @@
       </p:sp>
       <p:sp>
         <p:nvSpPr>
-          <p:cNvPr id="22" name="Text 20"/>
+          <p:cNvPr id="27" name="Text 25"/>
           <p:cNvSpPr/>
           <p:nvPr/>
         </p:nvSpPr>
@@ -6297,7 +6461,7 @@
       </p:sp>
       <p:sp>
         <p:nvSpPr>
-          <p:cNvPr id="23" name="Text 21"/>
+          <p:cNvPr id="28" name="Text 26"/>
           <p:cNvSpPr/>
           <p:nvPr/>
         </p:nvSpPr>
@@ -8604,7 +8768,7 @@
                 <a:ea typeface="Cambria" pitchFamily="34" charset="-122"/>
                 <a:cs typeface="Cambria" pitchFamily="34" charset="-120"/>
               </a:rPr>
-              <a:t>The second contract found three bugs</a:t>
+              <a:t>We measure it, and measuring keeps finding bugs</a:t>
             </a:r>
             <a:endParaRPr lang="en-US" sz="3800" dirty="0"/>
           </a:p>
@@ -8643,7 +8807,7 @@
                 <a:ea typeface="Calibri" pitchFamily="34" charset="-122"/>
                 <a:cs typeface="Calibri" pitchFamily="34" charset="-120"/>
               </a:rPr>
-              <a:t>Adding it was not a demo flourish. It was a test, and it failed usefully.</a:t>
+              <a:t>Every claim on the previous slide comes from a harness, not from watching one demo go well.</a:t>
             </a:r>
             <a:endParaRPr lang="en-US" sz="1500" dirty="0"/>
           </a:p>
@@ -9186,23 +9350,23 @@
         <p:spPr>
           <a:xfrm>
             <a:off x="8549640" y="2450592"/>
-            <a:ext cx="2743200" cy="914400"/>
-          </a:xfrm>
-          <a:prstGeom prst="rect">
-            <a:avLst/>
-          </a:prstGeom>
-          <a:noFill/>
-          <a:ln/>
-        </p:spPr>
-        <p:txBody>
-          <a:bodyPr wrap="square" lIns="0" tIns="0" rIns="0" bIns="0" rtlCol="0" anchor="ctr"/>
-          <a:lstStyle/>
-          <a:p>
-            <a:pPr indent="0" marL="0">
-              <a:buNone/>
-            </a:pPr>
-            <a:r>
-              <a:rPr lang="en-US" sz="5400" b="1" dirty="0">
+            <a:ext cx="2743200" cy="731520"/>
+          </a:xfrm>
+          <a:prstGeom prst="rect">
+            <a:avLst/>
+          </a:prstGeom>
+          <a:noFill/>
+          <a:ln/>
+        </p:spPr>
+        <p:txBody>
+          <a:bodyPr wrap="square" lIns="0" tIns="0" rIns="0" bIns="0" rtlCol="0" anchor="ctr"/>
+          <a:lstStyle/>
+          <a:p>
+            <a:pPr indent="0" marL="0">
+              <a:buNone/>
+            </a:pPr>
+            <a:r>
+              <a:rPr lang="en-US" sz="3800" b="1" dirty="0">
                 <a:solidFill>
                   <a:srgbClr val="4B3F9E"/>
                 </a:solidFill>
@@ -9210,9 +9374,9 @@
                 <a:ea typeface="Calibri" pitchFamily="34" charset="-122"/>
                 <a:cs typeface="Calibri" pitchFamily="34" charset="-120"/>
               </a:rPr>
-              <a:t>77</a:t>
-            </a:r>
-            <a:endParaRPr lang="en-US" sz="5400" dirty="0"/>
+              <a:t>28 / 39</a:t>
+            </a:r>
+            <a:endParaRPr lang="en-US" sz="3800" dirty="0"/>
           </a:p>
         </p:txBody>
       </p:sp>
@@ -9224,7 +9388,7 @@
         </p:nvSpPr>
         <p:spPr>
           <a:xfrm>
-            <a:off x="8549640" y="3291840"/>
+            <a:off x="8549640" y="3154680"/>
             <a:ext cx="2743200" cy="274320"/>
           </a:xfrm>
           <a:prstGeom prst="rect">
@@ -9241,7 +9405,7 @@
               <a:buNone/>
             </a:pPr>
             <a:r>
-              <a:rPr lang="en-US" sz="1100" spc="110" kern="0" dirty="0">
+              <a:rPr lang="en-US" sz="1100" spc="100" kern="0" dirty="0">
                 <a:solidFill>
                   <a:srgbClr val="5B6072"/>
                 </a:solidFill>
@@ -9249,7 +9413,7 @@
                 <a:ea typeface="Courier New" pitchFamily="34" charset="-122"/>
                 <a:cs typeface="Courier New" pitchFamily="34" charset="-120"/>
               </a:rPr>
-              <a:t>checks, no framework</a:t>
+              <a:t>exact, 37 defensible</a:t>
             </a:r>
             <a:endParaRPr lang="en-US" sz="1100" dirty="0"/>
           </a:p>
@@ -9263,8 +9427,8 @@
         </p:nvSpPr>
         <p:spPr>
           <a:xfrm>
-            <a:off x="8549640" y="3794760"/>
-            <a:ext cx="2743200" cy="1828800"/>
+            <a:off x="8549640" y="3657600"/>
+            <a:ext cx="2788920" cy="2011680"/>
           </a:xfrm>
           <a:prstGeom prst="rect">
             <a:avLst/>
@@ -9278,12 +9442,12 @@
           <a:p>
             <a:pPr indent="0" marL="0">
               <a:lnSpc>
-                <a:spcPts val="1700"/>
+                <a:spcPts val="1500"/>
               </a:lnSpc>
               <a:buNone/>
             </a:pPr>
             <a:r>
-              <a:rPr lang="en-US" sz="1200" dirty="0">
+              <a:rPr lang="en-US" sz="1150" dirty="0">
                 <a:solidFill>
                   <a:srgbClr val="5B6072"/>
                 </a:solidFill>
@@ -9291,9 +9455,38 @@
                 <a:ea typeface="Calibri" pitchFamily="34" charset="-122"/>
                 <a:cs typeface="Calibri" pitchFamily="34" charset="-120"/>
               </a:rPr>
-              <a:t>They cover what fails quietly: a fabricated quote, an invented price, a cache prefix that stops being stable, a due date one day out, a send path appearing where none should exist.</a:t>
-            </a:r>
-            <a:endParaRPr lang="en-US" sz="1200" dirty="0"/>
+              <a:t>Scored against messages labelled from the contract, not from what the system outputs. Every out-of-scope request found, none invented.</a:t>
+            </a:r>
+            <a:endParaRPr lang="en-US" sz="1150" dirty="0"/>
+          </a:p>
+          <a:p>
+            <a:pPr indent="0" marL="0">
+              <a:lnSpc>
+                <a:spcPts val="1500"/>
+              </a:lnSpc>
+              <a:buNone/>
+            </a:pPr>
+            <a:endParaRPr lang="en-US" sz="1150" dirty="0"/>
+          </a:p>
+          <a:p>
+            <a:pPr indent="0" marL="0">
+              <a:lnSpc>
+                <a:spcPts val="1500"/>
+              </a:lnSpc>
+              <a:buNone/>
+            </a:pPr>
+            <a:r>
+              <a:rPr lang="en-US" sz="1150" dirty="0">
+                <a:solidFill>
+                  <a:srgbClr val="5B6072"/>
+                </a:solidFill>
+                <a:latin typeface="Calibri" pitchFamily="34" charset="0"/>
+                <a:ea typeface="Calibri" pitchFamily="34" charset="-122"/>
+                <a:cs typeface="Calibri" pitchFamily="34" charset="-120"/>
+              </a:rPr>
+              <a:t>The harness caught a bug 93 unit tests missed — a citation from the wrong client's contract.</a:t>
+            </a:r>
+            <a:endParaRPr lang="en-US" sz="1150" dirty="0"/>
           </a:p>
         </p:txBody>
       </p:sp>

</xml_diff>

<commit_message>
docs: invoice checking, accounts, and the mailbox connection
The README gains the three surfaces added since it was last touched. The
invoice section leads with the line that is outside the signed contract and
payable anyway, because that is the case the feature exists for and the one a
simpler tool gets wrong.

The accounts section is mostly about isolation rather than about signing in,
which is the honest proportion: between paying customers, an id space assumed
to be scoped and not is somebody reading another person's client mail.

The connect section says plainly why there is no field for an emailed code.

In the deck the invoice does not take a slide of its own. It closes the
amendment slide instead, because a bill arriving for work agreed by email is
what that agreement is finally worth.

Co-Authored-By: Claude Opus 5 <noreply@anthropic.com>
</commit_message>
<xml_diff>
--- a/deck/chief-of-staff.pptx
+++ b/deck/chief-of-staff.pptx
@@ -1039,7 +1039,7 @@
           <a:p>
             <a:r>
               <a:rPr lang="en-US" dirty="0"/>
-              <a:t>The amendment records the condition they attached — start only after the Collections page. Agreeing on terms is not the same as agreeing, and dropping the terms overstates what was settled.</a:t>
+              <a:t>The amendment records the condition they attached — start only after the Collections page. Agreeing on terms is not the same as agreeing, and dropping the terms overstates what was settled. The same record is what lets the invoice check clear that line instead of disputing it.</a:t>
             </a:r>
             <a:endParaRPr lang="en-US" dirty="0"/>
           </a:p>
@@ -4113,7 +4113,7 @@
                 <a:ea typeface="Calibri" pitchFamily="34" charset="-122"/>
                 <a:cs typeface="Calibri" pitchFamily="34" charset="-120"/>
               </a:rPr>
-              <a:t>Tracks what changed</a:t>
+              <a:t>Checks the bill</a:t>
             </a:r>
             <a:endParaRPr lang="en-US" sz="1600" dirty="0"/>
           </a:p>
@@ -4155,7 +4155,7 @@
                 <a:ea typeface="Calibri" pitchFamily="34" charset="-122"/>
                 <a:cs typeface="Calibri" pitchFamily="34" charset="-120"/>
               </a:rPr>
-              <a:t>When the client agrees in writing to work the contract never covered, that agreement becomes scope — cited to their own words.</a:t>
+              <a:t>Every line on an invoice against the agreement as it now stands: payable under the contract, payable because it was agreed by email, or payable by nobody.</a:t>
             </a:r>
             <a:endParaRPr lang="en-US" sz="1200" dirty="0"/>
           </a:p>
@@ -5500,8 +5500,8 @@
         </p:nvSpPr>
         <p:spPr>
           <a:xfrm>
-            <a:off x="8138160" y="3858768"/>
-            <a:ext cx="3154680" cy="1828800"/>
+            <a:off x="8138160" y="3840480"/>
+            <a:ext cx="3154680" cy="1188720"/>
           </a:xfrm>
           <a:prstGeom prst="rect">
             <a:avLst/>
@@ -5529,6 +5529,87 @@
                 <a:cs typeface="Calibri" pitchFamily="34" charset="-120"/>
               </a:rPr>
               <a:t>A contractor writing “great, I'll start Monday” is enthusiasm, not agreement. That rule is in the code, because a model asked whether somebody agreed will find agreement in warmth.</a:t>
+            </a:r>
+            <a:endParaRPr lang="en-US" sz="1200" dirty="0"/>
+          </a:p>
+        </p:txBody>
+      </p:sp>
+      <p:sp>
+        <p:nvSpPr>
+          <p:cNvPr id="21" name="Text 19"/>
+          <p:cNvSpPr/>
+          <p:nvPr/>
+        </p:nvSpPr>
+        <p:spPr>
+          <a:xfrm>
+            <a:off x="8138160" y="5029200"/>
+            <a:ext cx="3108960" cy="237744"/>
+          </a:xfrm>
+          <a:prstGeom prst="rect">
+            <a:avLst/>
+          </a:prstGeom>
+          <a:noFill/>
+          <a:ln/>
+        </p:spPr>
+        <p:txBody>
+          <a:bodyPr wrap="square" lIns="0" tIns="0" rIns="0" bIns="0" rtlCol="0" anchor="ctr"/>
+          <a:lstStyle/>
+          <a:p>
+            <a:pPr indent="0" marL="0">
+              <a:buNone/>
+            </a:pPr>
+            <a:r>
+              <a:rPr lang="en-US" sz="1000" spc="130" kern="0" dirty="0">
+                <a:solidFill>
+                  <a:srgbClr val="A9A2D8"/>
+                </a:solidFill>
+                <a:latin typeface="Courier New" pitchFamily="34" charset="0"/>
+                <a:ea typeface="Courier New" pitchFamily="34" charset="-122"/>
+                <a:cs typeface="Courier New" pitchFamily="34" charset="-120"/>
+              </a:rPr>
+              <a:t>AND WHEN THE BILL ARRIVES</a:t>
+            </a:r>
+            <a:endParaRPr lang="en-US" sz="1000" dirty="0"/>
+          </a:p>
+        </p:txBody>
+      </p:sp>
+      <p:sp>
+        <p:nvSpPr>
+          <p:cNvPr id="22" name="Text 20"/>
+          <p:cNvSpPr/>
+          <p:nvPr/>
+        </p:nvSpPr>
+        <p:spPr>
+          <a:xfrm>
+            <a:off x="8138160" y="5321808"/>
+            <a:ext cx="3154680" cy="548640"/>
+          </a:xfrm>
+          <a:prstGeom prst="rect">
+            <a:avLst/>
+          </a:prstGeom>
+          <a:noFill/>
+          <a:ln/>
+        </p:spPr>
+        <p:txBody>
+          <a:bodyPr wrap="square" lIns="0" tIns="0" rIns="0" bIns="0" rtlCol="0" anchor="ctr"/>
+          <a:lstStyle/>
+          <a:p>
+            <a:pPr indent="0" marL="0">
+              <a:lnSpc>
+                <a:spcPts val="1600"/>
+              </a:lnSpc>
+              <a:buNone/>
+            </a:pPr>
+            <a:r>
+              <a:rPr lang="en-US" sz="1200" dirty="0">
+                <a:solidFill>
+                  <a:srgbClr val="FFFFFF"/>
+                </a:solidFill>
+                <a:latin typeface="Calibri" pitchFamily="34" charset="0"/>
+                <a:ea typeface="Calibri" pitchFamily="34" charset="-122"/>
+                <a:cs typeface="Calibri" pitchFamily="34" charset="-120"/>
+              </a:rPr>
+              <a:t>That line is payable — cited to their email, not the contract.</a:t>
             </a:r>
             <a:endParaRPr lang="en-US" sz="1200" dirty="0"/>
           </a:p>

</xml_diff>